<commit_message>
Harden methodology and add confirmation study design
</commit_message>
<xml_diff>
--- a/docs/assets/bizhallu_ai_reliability_deck.pptx
+++ b/docs/assets/bizhallu_ai_reliability_deck.pptx
@@ -2,120 +2,25 @@
 <file path=ppt/presentation.xml><?xml version="1.0" encoding="utf-8"?>
 <p:presentation xmlns:p="http://schemas.openxmlformats.org/presentationml/2006/main">
   <p:sldMasterIdLst>
-    <p:sldMasterId xmlns:r="http://schemas.openxmlformats.org/officeDocument/2006/relationships" id="2147483648" r:id="R949383954d024a42"/>
+    <p:sldMasterId xmlns:r="http://schemas.openxmlformats.org/officeDocument/2006/relationships" id="2147483648" r:id="R652c0a1cf1f14834"/>
   </p:sldMasterIdLst>
   <p:notesMasterIdLst>
-    <p:notesMasterId xmlns:r="http://schemas.openxmlformats.org/officeDocument/2006/relationships" r:id="R28fa751bad694ced"/>
+    <p:notesMasterId xmlns:r="http://schemas.openxmlformats.org/officeDocument/2006/relationships" r:id="Rda56b1c887b34362"/>
   </p:notesMasterIdLst>
   <p:sldIdLst>
-    <p:sldId xmlns:r="http://schemas.openxmlformats.org/officeDocument/2006/relationships" id="256" r:id="Rcc3330ff2d574ea2"/>
-    <p:sldId xmlns:r="http://schemas.openxmlformats.org/officeDocument/2006/relationships" id="257" r:id="R18b5d6b0ad794adb"/>
-    <p:sldId xmlns:r="http://schemas.openxmlformats.org/officeDocument/2006/relationships" id="258" r:id="R99f47494e4534b21"/>
-    <p:sldId xmlns:r="http://schemas.openxmlformats.org/officeDocument/2006/relationships" id="259" r:id="R60d4e8e1620e42e2"/>
-    <p:sldId xmlns:r="http://schemas.openxmlformats.org/officeDocument/2006/relationships" id="260" r:id="R8a9fa9084081486b"/>
-    <p:sldId xmlns:r="http://schemas.openxmlformats.org/officeDocument/2006/relationships" id="261" r:id="R283a9b506e414dca"/>
-    <p:sldId xmlns:r="http://schemas.openxmlformats.org/officeDocument/2006/relationships" id="262" r:id="R9a61c921f89a4b46"/>
-    <p:sldId xmlns:r="http://schemas.openxmlformats.org/officeDocument/2006/relationships" id="263" r:id="Rcbb35c7aecaa4b54"/>
-    <p:sldId xmlns:r="http://schemas.openxmlformats.org/officeDocument/2006/relationships" id="264" r:id="R85d86c790cce4467"/>
-    <p:sldId xmlns:r="http://schemas.openxmlformats.org/officeDocument/2006/relationships" id="265" r:id="R7ccdc69b6b044d49"/>
+    <p:sldId xmlns:r="http://schemas.openxmlformats.org/officeDocument/2006/relationships" id="256" r:id="R68e2f439cca84b1b"/>
+    <p:sldId xmlns:r="http://schemas.openxmlformats.org/officeDocument/2006/relationships" id="257" r:id="Rdea64601ff00407a"/>
+    <p:sldId xmlns:r="http://schemas.openxmlformats.org/officeDocument/2006/relationships" id="258" r:id="R00ffc12bd6b94910"/>
+    <p:sldId xmlns:r="http://schemas.openxmlformats.org/officeDocument/2006/relationships" id="259" r:id="R5f5096d26cc24efe"/>
+    <p:sldId xmlns:r="http://schemas.openxmlformats.org/officeDocument/2006/relationships" id="260" r:id="Re29a32f1f9f7487f"/>
+    <p:sldId xmlns:r="http://schemas.openxmlformats.org/officeDocument/2006/relationships" id="261" r:id="Ra4853dc81e114812"/>
+    <p:sldId xmlns:r="http://schemas.openxmlformats.org/officeDocument/2006/relationships" id="262" r:id="Rbc013149e9734b99"/>
+    <p:sldId xmlns:r="http://schemas.openxmlformats.org/officeDocument/2006/relationships" id="263" r:id="R4f7084b50a594704"/>
+    <p:sldId xmlns:r="http://schemas.openxmlformats.org/officeDocument/2006/relationships" id="264" r:id="Rc31247db5a4540e0"/>
+    <p:sldId xmlns:r="http://schemas.openxmlformats.org/officeDocument/2006/relationships" id="265" r:id="R92623c6fa6734fe5"/>
   </p:sldIdLst>
   <p:sldSz cx="12192000" cy="6858000"/>
   <p:notesSz cx="6858000" cy="9144000"/>
-  <p:defaultTextStyle>
-    <a:defPPr xmlns:a="http://schemas.openxmlformats.org/drawingml/2006/main">
-      <a:defRPr lang="en-US"/>
-    </a:defPPr>
-    <a:lvl1pPr xmlns:a="http://schemas.openxmlformats.org/drawingml/2006/main" marL="0" indent="0" algn="l" defTabSz="914400">
-      <a:defRPr sz="1800" kern="1200">
-        <a:solidFill>
-          <a:schemeClr val="tx1"/>
-        </a:solidFill>
-        <a:latin typeface="+mn-lt"/>
-        <a:ea typeface="+mn-ea"/>
-        <a:cs typeface="+mn-cs"/>
-      </a:defRPr>
-    </a:lvl1pPr>
-    <a:lvl2pPr xmlns:a="http://schemas.openxmlformats.org/drawingml/2006/main" marL="457200" indent="0" algn="l" defTabSz="914400">
-      <a:defRPr sz="1800" kern="1200">
-        <a:solidFill>
-          <a:schemeClr val="tx1"/>
-        </a:solidFill>
-        <a:latin typeface="+mn-lt"/>
-        <a:ea typeface="+mn-ea"/>
-        <a:cs typeface="+mn-cs"/>
-      </a:defRPr>
-    </a:lvl2pPr>
-    <a:lvl3pPr xmlns:a="http://schemas.openxmlformats.org/drawingml/2006/main" marL="914400" indent="0" algn="l" defTabSz="914400">
-      <a:defRPr sz="1800" kern="1200">
-        <a:solidFill>
-          <a:schemeClr val="tx1"/>
-        </a:solidFill>
-        <a:latin typeface="+mn-lt"/>
-        <a:ea typeface="+mn-ea"/>
-        <a:cs typeface="+mn-cs"/>
-      </a:defRPr>
-    </a:lvl3pPr>
-    <a:lvl4pPr xmlns:a="http://schemas.openxmlformats.org/drawingml/2006/main" marL="1371600" indent="0" algn="l" defTabSz="914400">
-      <a:defRPr sz="1800" kern="1200">
-        <a:solidFill>
-          <a:schemeClr val="tx1"/>
-        </a:solidFill>
-        <a:latin typeface="+mn-lt"/>
-        <a:ea typeface="+mn-ea"/>
-        <a:cs typeface="+mn-cs"/>
-      </a:defRPr>
-    </a:lvl4pPr>
-    <a:lvl5pPr xmlns:a="http://schemas.openxmlformats.org/drawingml/2006/main" marL="1828800" indent="0" algn="l" defTabSz="914400">
-      <a:defRPr sz="1800" kern="1200">
-        <a:solidFill>
-          <a:schemeClr val="tx1"/>
-        </a:solidFill>
-        <a:latin typeface="+mn-lt"/>
-        <a:ea typeface="+mn-ea"/>
-        <a:cs typeface="+mn-cs"/>
-      </a:defRPr>
-    </a:lvl5pPr>
-    <a:lvl6pPr xmlns:a="http://schemas.openxmlformats.org/drawingml/2006/main" marL="2286000" indent="0" algn="l" defTabSz="914400">
-      <a:defRPr sz="1800" kern="1200">
-        <a:solidFill>
-          <a:schemeClr val="tx1"/>
-        </a:solidFill>
-        <a:latin typeface="+mn-lt"/>
-        <a:ea typeface="+mn-ea"/>
-        <a:cs typeface="+mn-cs"/>
-      </a:defRPr>
-    </a:lvl6pPr>
-    <a:lvl7pPr xmlns:a="http://schemas.openxmlformats.org/drawingml/2006/main" marL="2743200" indent="0" algn="l" defTabSz="914400">
-      <a:defRPr sz="1800" kern="1200">
-        <a:solidFill>
-          <a:schemeClr val="tx1"/>
-        </a:solidFill>
-        <a:latin typeface="+mn-lt"/>
-        <a:ea typeface="+mn-ea"/>
-        <a:cs typeface="+mn-cs"/>
-      </a:defRPr>
-    </a:lvl7pPr>
-    <a:lvl8pPr xmlns:a="http://schemas.openxmlformats.org/drawingml/2006/main" marL="3200400" indent="0" algn="l" defTabSz="914400">
-      <a:defRPr sz="1800" kern="1200">
-        <a:solidFill>
-          <a:schemeClr val="tx1"/>
-        </a:solidFill>
-        <a:latin typeface="+mn-lt"/>
-        <a:ea typeface="+mn-ea"/>
-        <a:cs typeface="+mn-cs"/>
-      </a:defRPr>
-    </a:lvl8pPr>
-    <a:lvl9pPr xmlns:a="http://schemas.openxmlformats.org/drawingml/2006/main" marL="3657600" indent="0" algn="l" defTabSz="914400">
-      <a:defRPr sz="1800" kern="1200">
-        <a:solidFill>
-          <a:schemeClr val="tx1"/>
-        </a:solidFill>
-        <a:latin typeface="+mn-lt"/>
-        <a:ea typeface="+mn-ea"/>
-        <a:cs typeface="+mn-cs"/>
-      </a:defRPr>
-    </a:lvl9pPr>
-  </p:defaultTextStyle>
 </p:presentation>
 </file>
 
@@ -261,7 +166,7 @@
 </p:notesMaster>
 </file>
 
-<file path=ppt/notesMasters/theme/theme2.xml><?xml version="1.0" encoding="utf-8"?>
+<file path=ppt/notesMasters/theme/theme3.xml><?xml version="1.0" encoding="utf-8"?>
 <a:theme xmlns:a="http://schemas.openxmlformats.org/drawingml/2006/main" name="ChatGPT">
   <a:themeElements>
     <a:clrScheme name="ChatGPT">
@@ -498,7 +403,26 @@
         <p:txBody>
           <a:bodyPr xmlns:a="http://schemas.openxmlformats.org/drawingml/2006/main"/>
           <a:lstStyle xmlns:a="http://schemas.openxmlformats.org/drawingml/2006/main"/>
-          <a:p xmlns:a="http://schemas.openxmlformats.org/drawingml/2006/main"/>
+          <a:p xmlns:a="http://schemas.openxmlformats.org/drawingml/2006/main">
+            <a:r>
+              <a:t>[Sources]</a:t>
+            </a:r>
+          </a:p>
+          <a:p xmlns:a="http://schemas.openxmlformats.org/drawingml/2006/main">
+            <a:r>
+              <a:t>- UCI Online Retail: https://doi.org/10.24432/C5BW33</a:t>
+            </a:r>
+          </a:p>
+          <a:p xmlns:a="http://schemas.openxmlformats.org/drawingml/2006/main">
+            <a:r>
+              <a:t>- README.md</a:t>
+            </a:r>
+          </a:p>
+          <a:p xmlns:a="http://schemas.openxmlformats.org/drawingml/2006/main">
+            <a:r>
+              <a:t>- reports/full100_detector_interpretation_summary.json</a:t>
+            </a:r>
+          </a:p>
         </p:txBody>
       </p:sp>
       <p:sp>
@@ -564,7 +488,21 @@
         <p:txBody>
           <a:bodyPr xmlns:a="http://schemas.openxmlformats.org/drawingml/2006/main"/>
           <a:lstStyle xmlns:a="http://schemas.openxmlformats.org/drawingml/2006/main"/>
-          <a:p xmlns:a="http://schemas.openxmlformats.org/drawingml/2006/main"/>
+          <a:p xmlns:a="http://schemas.openxmlformats.org/drawingml/2006/main">
+            <a:r>
+              <a:t>[Sources]</a:t>
+            </a:r>
+          </a:p>
+          <a:p xmlns:a="http://schemas.openxmlformats.org/drawingml/2006/main">
+            <a:r>
+              <a:t>- README.md</a:t>
+            </a:r>
+          </a:p>
+          <a:p xmlns:a="http://schemas.openxmlformats.org/drawingml/2006/main">
+            <a:r>
+              <a:t>- reports/bizhallu_career_package.md</a:t>
+            </a:r>
+          </a:p>
         </p:txBody>
       </p:sp>
       <p:sp>
@@ -630,7 +568,21 @@
         <p:txBody>
           <a:bodyPr xmlns:a="http://schemas.openxmlformats.org/drawingml/2006/main"/>
           <a:lstStyle xmlns:a="http://schemas.openxmlformats.org/drawingml/2006/main"/>
-          <a:p xmlns:a="http://schemas.openxmlformats.org/drawingml/2006/main"/>
+          <a:p xmlns:a="http://schemas.openxmlformats.org/drawingml/2006/main">
+            <a:r>
+              <a:t>[Sources]</a:t>
+            </a:r>
+          </a:p>
+          <a:p xmlns:a="http://schemas.openxmlformats.org/drawingml/2006/main">
+            <a:r>
+              <a:t>- reports/bizhallu_demo_v2_data.json</a:t>
+            </a:r>
+          </a:p>
+          <a:p xmlns:a="http://schemas.openxmlformats.org/drawingml/2006/main">
+            <a:r>
+              <a:t>- docs/experiment_design.md</a:t>
+            </a:r>
+          </a:p>
         </p:txBody>
       </p:sp>
       <p:sp>
@@ -696,7 +648,26 @@
         <p:txBody>
           <a:bodyPr xmlns:a="http://schemas.openxmlformats.org/drawingml/2006/main"/>
           <a:lstStyle xmlns:a="http://schemas.openxmlformats.org/drawingml/2006/main"/>
-          <a:p xmlns:a="http://schemas.openxmlformats.org/drawingml/2006/main"/>
+          <a:p xmlns:a="http://schemas.openxmlformats.org/drawingml/2006/main">
+            <a:r>
+              <a:t>[Sources]</a:t>
+            </a:r>
+          </a:p>
+          <a:p xmlns:a="http://schemas.openxmlformats.org/drawingml/2006/main">
+            <a:r>
+              <a:t>- docs/experiment_design.md</a:t>
+            </a:r>
+          </a:p>
+          <a:p xmlns:a="http://schemas.openxmlformats.org/drawingml/2006/main">
+            <a:r>
+              <a:t>- src/evaluate_detector_split_metrics.py</a:t>
+            </a:r>
+          </a:p>
+          <a:p xmlns:a="http://schemas.openxmlformats.org/drawingml/2006/main">
+            <a:r>
+              <a:t>- reports/full100_detector_interpretation_summary.json</a:t>
+            </a:r>
+          </a:p>
         </p:txBody>
       </p:sp>
       <p:sp>
@@ -762,7 +733,26 @@
         <p:txBody>
           <a:bodyPr xmlns:a="http://schemas.openxmlformats.org/drawingml/2006/main"/>
           <a:lstStyle xmlns:a="http://schemas.openxmlformats.org/drawingml/2006/main"/>
-          <a:p xmlns:a="http://schemas.openxmlformats.org/drawingml/2006/main"/>
+          <a:p xmlns:a="http://schemas.openxmlformats.org/drawingml/2006/main">
+            <a:r>
+              <a:t>[Sources]</a:t>
+            </a:r>
+          </a:p>
+          <a:p xmlns:a="http://schemas.openxmlformats.org/drawingml/2006/main">
+            <a:r>
+              <a:t>- UCI Online Retail: https://doi.org/10.24432/C5BW33</a:t>
+            </a:r>
+          </a:p>
+          <a:p xmlns:a="http://schemas.openxmlformats.org/drawingml/2006/main">
+            <a:r>
+              <a:t>- data/processed/data_quality_report.json</a:t>
+            </a:r>
+          </a:p>
+          <a:p xmlns:a="http://schemas.openxmlformats.org/drawingml/2006/main">
+            <a:r>
+              <a:t>- data/processed/business_questions_gold_report.json</a:t>
+            </a:r>
+          </a:p>
         </p:txBody>
       </p:sp>
       <p:sp>
@@ -828,7 +818,26 @@
         <p:txBody>
           <a:bodyPr xmlns:a="http://schemas.openxmlformats.org/drawingml/2006/main"/>
           <a:lstStyle xmlns:a="http://schemas.openxmlformats.org/drawingml/2006/main"/>
-          <a:p xmlns:a="http://schemas.openxmlformats.org/drawingml/2006/main"/>
+          <a:p xmlns:a="http://schemas.openxmlformats.org/drawingml/2006/main">
+            <a:r>
+              <a:t>[Sources]</a:t>
+            </a:r>
+          </a:p>
+          <a:p xmlns:a="http://schemas.openxmlformats.org/drawingml/2006/main">
+            <a:r>
+              <a:t>- data/annotations/README.md</a:t>
+            </a:r>
+          </a:p>
+          <a:p xmlns:a="http://schemas.openxmlformats.org/drawingml/2006/main">
+            <a:r>
+              <a:t>- data/annotations/annotation_guidelines.md</a:t>
+            </a:r>
+          </a:p>
+          <a:p xmlns:a="http://schemas.openxmlformats.org/drawingml/2006/main">
+            <a:r>
+              <a:t>- docs/current_state_audit.md</a:t>
+            </a:r>
+          </a:p>
         </p:txBody>
       </p:sp>
       <p:sp>
@@ -894,7 +903,21 @@
         <p:txBody>
           <a:bodyPr xmlns:a="http://schemas.openxmlformats.org/drawingml/2006/main"/>
           <a:lstStyle xmlns:a="http://schemas.openxmlformats.org/drawingml/2006/main"/>
-          <a:p xmlns:a="http://schemas.openxmlformats.org/drawingml/2006/main"/>
+          <a:p xmlns:a="http://schemas.openxmlformats.org/drawingml/2006/main">
+            <a:r>
+              <a:t>[Sources]</a:t>
+            </a:r>
+          </a:p>
+          <a:p xmlns:a="http://schemas.openxmlformats.org/drawingml/2006/main">
+            <a:r>
+              <a:t>- reports/full100_detector_interpretation_summary.json</a:t>
+            </a:r>
+          </a:p>
+          <a:p xmlns:a="http://schemas.openxmlformats.org/drawingml/2006/main">
+            <a:r>
+              <a:t>- results/full100_draft_detector_family_summary.csv</a:t>
+            </a:r>
+          </a:p>
         </p:txBody>
       </p:sp>
       <p:sp>
@@ -960,7 +983,21 @@
         <p:txBody>
           <a:bodyPr xmlns:a="http://schemas.openxmlformats.org/drawingml/2006/main"/>
           <a:lstStyle xmlns:a="http://schemas.openxmlformats.org/drawingml/2006/main"/>
-          <a:p xmlns:a="http://schemas.openxmlformats.org/drawingml/2006/main"/>
+          <a:p xmlns:a="http://schemas.openxmlformats.org/drawingml/2006/main">
+            <a:r>
+              <a:t>[Sources]</a:t>
+            </a:r>
+          </a:p>
+          <a:p xmlns:a="http://schemas.openxmlformats.org/drawingml/2006/main">
+            <a:r>
+              <a:t>- results/full100_draft_simple_split_report.json</a:t>
+            </a:r>
+          </a:p>
+          <a:p xmlns:a="http://schemas.openxmlformats.org/drawingml/2006/main">
+            <a:r>
+              <a:t>- results/full100_draft_energy_split_report.json</a:t>
+            </a:r>
+          </a:p>
         </p:txBody>
       </p:sp>
       <p:sp>
@@ -1026,7 +1063,21 @@
         <p:txBody>
           <a:bodyPr xmlns:a="http://schemas.openxmlformats.org/drawingml/2006/main"/>
           <a:lstStyle xmlns:a="http://schemas.openxmlformats.org/drawingml/2006/main"/>
-          <a:p xmlns:a="http://schemas.openxmlformats.org/drawingml/2006/main"/>
+          <a:p xmlns:a="http://schemas.openxmlformats.org/drawingml/2006/main">
+            <a:r>
+              <a:t>[Sources]</a:t>
+            </a:r>
+          </a:p>
+          <a:p xmlns:a="http://schemas.openxmlformats.org/drawingml/2006/main">
+            <a:r>
+              <a:t>- docs/assets/full100_draft_detector_error_review_examples.csv</a:t>
+            </a:r>
+          </a:p>
+          <a:p xmlns:a="http://schemas.openxmlformats.org/drawingml/2006/main">
+            <a:r>
+              <a:t>- reports/full100_detector_interpretation_summary.json</a:t>
+            </a:r>
+          </a:p>
         </p:txBody>
       </p:sp>
       <p:sp>
@@ -1092,7 +1143,21 @@
         <p:txBody>
           <a:bodyPr xmlns:a="http://schemas.openxmlformats.org/drawingml/2006/main"/>
           <a:lstStyle xmlns:a="http://schemas.openxmlformats.org/drawingml/2006/main"/>
-          <a:p xmlns:a="http://schemas.openxmlformats.org/drawingml/2006/main"/>
+          <a:p xmlns:a="http://schemas.openxmlformats.org/drawingml/2006/main">
+            <a:r>
+              <a:t>[Sources]</a:t>
+            </a:r>
+          </a:p>
+          <a:p xmlns:a="http://schemas.openxmlformats.org/drawingml/2006/main">
+            <a:r>
+              <a:t>- reports/bizhallu_demo_v2_data.json</a:t>
+            </a:r>
+          </a:p>
+          <a:p xmlns:a="http://schemas.openxmlformats.org/drawingml/2006/main">
+            <a:r>
+              <a:t>- reports/bizhallu_portfolio_demo_summary.json</a:t>
+            </a:r>
+          </a:p>
         </p:txBody>
       </p:sp>
       <p:sp>
@@ -1120,7 +1185,7 @@
 </p:notes>
 </file>
 
-<file path=ppt/slideLayouts/slideLayout2.xml><?xml version="1.0" encoding="utf-8"?>
+<file path=ppt/slideLayouts/slideLayout1.xml><?xml version="1.0" encoding="utf-8"?>
 <p:sldLayout xmlns:p="http://schemas.openxmlformats.org/presentationml/2006/main" type="title">
   <p:cSld name="Title Slide">
     <p:spTree>
@@ -1158,7 +1223,7 @@
   </p:cSld>
   <p:clrMap bg1="lt1" tx1="dk1" bg2="lt2" tx2="dk2" accent1="accent1" accent2="accent2" accent3="accent3" accent4="accent4" accent5="accent5" accent6="accent6" hlink="hlink" folHlink="folHlink"/>
   <p:sldLayoutIdLst>
-    <p:sldLayoutId xmlns:r="http://schemas.openxmlformats.org/officeDocument/2006/relationships" id="2147483649" r:id="Rf68403d474a84fb7"/>
+    <p:sldLayoutId xmlns:r="http://schemas.openxmlformats.org/officeDocument/2006/relationships" id="2147483649" r:id="R20121854063c4c7a"/>
   </p:sldLayoutIdLst>
   <p:txStyles>
     <p:titleStyle>
@@ -1438,6 +1503,205 @@
     </p:otherStyle>
   </p:txStyles>
 </p:sldMaster>
+</file>
+
+<file path=ppt/slideMasters/theme/theme2.xml><?xml version="1.0" encoding="utf-8"?>
+<a:theme xmlns:a="http://schemas.openxmlformats.org/drawingml/2006/main" name="ChatGPT">
+  <a:themeElements>
+    <a:clrScheme name="ChatGPT">
+      <a:dk1>
+        <a:srgbClr val="000000"/>
+      </a:dk1>
+      <a:lt1>
+        <a:srgbClr val="FFFFFF"/>
+      </a:lt1>
+      <a:dk2>
+        <a:srgbClr val="0E2841"/>
+      </a:dk2>
+      <a:lt2>
+        <a:srgbClr val="E8E8E8"/>
+      </a:lt2>
+      <a:accent1>
+        <a:srgbClr val="156082"/>
+      </a:accent1>
+      <a:accent2>
+        <a:srgbClr val="E97132"/>
+      </a:accent2>
+      <a:accent3>
+        <a:srgbClr val="196B24"/>
+      </a:accent3>
+      <a:accent4>
+        <a:srgbClr val="0F9ED5"/>
+      </a:accent4>
+      <a:accent5>
+        <a:srgbClr val="A02B93"/>
+      </a:accent5>
+      <a:accent6>
+        <a:srgbClr val="4EA72E"/>
+      </a:accent6>
+      <a:hlink>
+        <a:srgbClr val="467886"/>
+      </a:hlink>
+      <a:folHlink>
+        <a:srgbClr val="96607D"/>
+      </a:folHlink>
+    </a:clrScheme>
+    <a:fontScheme name="Office">
+      <a:majorFont>
+        <a:latin typeface="Calibri Light"/>
+        <a:ea typeface="Calibri Light"/>
+        <a:cs typeface="Calibri Light"/>
+      </a:majorFont>
+      <a:minorFont>
+        <a:latin typeface="Calibri"/>
+        <a:ea typeface="Calibri"/>
+        <a:cs typeface="Calibri"/>
+      </a:minorFont>
+    </a:fontScheme>
+    <a:fmtScheme name="ChatGPT">
+      <a:fillStyleLst>
+        <a:solidFill>
+          <a:schemeClr val="phClr"/>
+        </a:solidFill>
+        <a:solidFill>
+          <a:schemeClr val="dk1"/>
+        </a:solidFill>
+        <a:solidFill>
+          <a:schemeClr val="accent1"/>
+        </a:solidFill>
+      </a:fillStyleLst>
+      <a:lnStyleLst>
+        <a:ln w="12700">
+          <a:solidFill>
+            <a:schemeClr val="phClr"/>
+          </a:solidFill>
+          <a:prstDash val="solid"/>
+        </a:ln>
+        <a:ln w="19050">
+          <a:solidFill>
+            <a:schemeClr val="phClr"/>
+          </a:solidFill>
+          <a:prstDash val="solid"/>
+        </a:ln>
+        <a:ln w="25400">
+          <a:solidFill>
+            <a:schemeClr val="phClr"/>
+          </a:solidFill>
+          <a:prstDash val="solid"/>
+        </a:ln>
+      </a:lnStyleLst>
+      <a:effectStyleLst>
+        <a:effectStyle>
+          <a:effectLst/>
+        </a:effectStyle>
+        <a:effectStyle>
+          <a:effectLst/>
+        </a:effectStyle>
+        <a:effectStyle>
+          <a:effectLst>
+            <a:outerShdw blurRad="57150" dist="19050" dir="5400000">
+              <a:srgbClr val="000000">
+                <a:alpha val="16000"/>
+              </a:srgbClr>
+            </a:outerShdw>
+          </a:effectLst>
+        </a:effectStyle>
+        <a:effectStyle>
+          <a:effectLst>
+            <a:outerShdw blurRad="19050" dist="9525" dir="5400000">
+              <a:srgbClr val="000000">
+                <a:alpha val="6000"/>
+              </a:srgbClr>
+            </a:outerShdw>
+          </a:effectLst>
+        </a:effectStyle>
+        <a:effectStyle>
+          <a:effectLst>
+            <a:outerShdw blurRad="28575" dist="9525" dir="5400000">
+              <a:srgbClr val="000000">
+                <a:alpha val="8000"/>
+              </a:srgbClr>
+            </a:outerShdw>
+          </a:effectLst>
+        </a:effectStyle>
+        <a:effectStyle>
+          <a:effectLst>
+            <a:outerShdw blurRad="57150" dist="19050" dir="5400000">
+              <a:srgbClr val="000000">
+                <a:alpha val="10000"/>
+              </a:srgbClr>
+            </a:outerShdw>
+          </a:effectLst>
+        </a:effectStyle>
+        <a:effectStyle>
+          <a:effectLst>
+            <a:outerShdw blurRad="114300" dist="38100" dir="5400000">
+              <a:srgbClr val="000000">
+                <a:alpha val="12000"/>
+              </a:srgbClr>
+            </a:outerShdw>
+          </a:effectLst>
+        </a:effectStyle>
+        <a:effectStyle>
+          <a:effectLst>
+            <a:outerShdw blurRad="171450" dist="57150" dir="5400000">
+              <a:srgbClr val="000000">
+                <a:alpha val="16000"/>
+              </a:srgbClr>
+            </a:outerShdw>
+          </a:effectLst>
+        </a:effectStyle>
+        <a:effectStyle>
+          <a:effectLst>
+            <a:outerShdw blurRad="266700" dist="95250" dir="5400000">
+              <a:srgbClr val="000000">
+                <a:alpha val="24000"/>
+              </a:srgbClr>
+            </a:outerShdw>
+          </a:effectLst>
+        </a:effectStyle>
+      </a:effectStyleLst>
+      <a:bgFillStyleLst>
+        <a:solidFill>
+          <a:schemeClr val="phClr"/>
+        </a:solidFill>
+        <a:solidFill>
+          <a:schemeClr val="phClr">
+            <a:tint val="95000"/>
+            <a:satMod val="170000"/>
+          </a:schemeClr>
+        </a:solidFill>
+        <a:gradFill>
+          <a:gsLst>
+            <a:gs pos="0">
+              <a:schemeClr val="phClr">
+                <a:tint val="93000"/>
+                <a:shade val="98000"/>
+                <a:lumMod val="102000"/>
+                <a:satMod val="150000"/>
+              </a:schemeClr>
+            </a:gs>
+            <a:gs pos="50000">
+              <a:schemeClr val="phClr">
+                <a:tint val="98000"/>
+                <a:shade val="90000"/>
+                <a:lumMod val="103000"/>
+                <a:satMod val="130000"/>
+              </a:schemeClr>
+            </a:gs>
+            <a:gs pos="100000">
+              <a:schemeClr val="phClr">
+                <a:shade val="63000"/>
+                <a:satMod val="120000"/>
+              </a:schemeClr>
+            </a:gs>
+          </a:gsLst>
+          <a:lin ang="5400000" scaled="0"/>
+        </a:gradFill>
+      </a:bgFillStyleLst>
+    </a:fmtScheme>
+  </a:themeElements>
+</a:theme>
 </file>
 
 <file path=ppt/slides/slide1.xml><?xml version="1.0" encoding="utf-8"?>
@@ -1461,7 +1725,7 @@
       </p:grpSpPr>
       <p:sp>
         <p:nvSpPr>
-          <p:cNvPr id="1" name="">
+          <p:cNvPr id="30" name="">
             <a:extLst xmlns:a="http://schemas.openxmlformats.org/drawingml/2006/main">
               <a:ext uri="{FF2B5EF4-FFF2-40B4-BE49-F238E27FC236}">
                 <a16:creationId xmlns:a16="http://schemas.microsoft.com/office/drawing/2014/main" id="{1FE310A4-B3C8-4615-8E4C-D9EE961EFDF9}"/>
@@ -1500,6 +1764,7 @@
           <a:lstStyle xmlns:a="http://schemas.openxmlformats.org/drawingml/2006/main"/>
           <a:p xmlns:a="http://schemas.openxmlformats.org/drawingml/2006/main">
             <a:pPr algn="l">
+              <a:buNone/>
               <a:defRPr sz="975" b="1">
                 <a:solidFill>
                   <a:srgbClr val="0066CC"/>
@@ -1597,6 +1862,7 @@
           <a:lstStyle xmlns:a="http://schemas.openxmlformats.org/drawingml/2006/main"/>
           <a:p xmlns:a="http://schemas.openxmlformats.org/drawingml/2006/main">
             <a:pPr algn="r">
+              <a:buNone/>
               <a:defRPr sz="900" b="0">
                 <a:solidFill>
                   <a:srgbClr val="6E6E73"/>
@@ -1661,6 +1927,7 @@
           <a:lstStyle xmlns:a="http://schemas.openxmlformats.org/drawingml/2006/main"/>
           <a:p xmlns:a="http://schemas.openxmlformats.org/drawingml/2006/main">
             <a:pPr algn="l">
+              <a:buNone/>
               <a:defRPr sz="4125" b="1">
                 <a:solidFill>
                   <a:srgbClr val="1D1D1F"/>
@@ -1725,6 +1992,7 @@
           <a:lstStyle xmlns:a="http://schemas.openxmlformats.org/drawingml/2006/main"/>
           <a:p xmlns:a="http://schemas.openxmlformats.org/drawingml/2006/main">
             <a:pPr algn="l">
+              <a:buNone/>
               <a:defRPr sz="1800" b="0">
                 <a:solidFill>
                   <a:srgbClr val="2F3A45"/>
@@ -1789,6 +2057,7 @@
           <a:lstStyle xmlns:a="http://schemas.openxmlformats.org/drawingml/2006/main"/>
           <a:p xmlns:a="http://schemas.openxmlformats.org/drawingml/2006/main">
             <a:pPr algn="l">
+              <a:buNone/>
               <a:defRPr sz="1350" b="0">
                 <a:solidFill>
                   <a:srgbClr val="6E6E73"/>
@@ -1886,6 +2155,7 @@
           <a:lstStyle xmlns:a="http://schemas.openxmlformats.org/drawingml/2006/main"/>
           <a:p xmlns:a="http://schemas.openxmlformats.org/drawingml/2006/main">
             <a:pPr algn="l">
+              <a:buNone/>
               <a:defRPr sz="2175" b="1">
                 <a:solidFill>
                   <a:srgbClr val="0066CC"/>
@@ -1950,6 +2220,7 @@
           <a:lstStyle xmlns:a="http://schemas.openxmlformats.org/drawingml/2006/main"/>
           <a:p xmlns:a="http://schemas.openxmlformats.org/drawingml/2006/main">
             <a:pPr algn="l">
+              <a:buNone/>
               <a:defRPr sz="900" b="0">
                 <a:solidFill>
                   <a:srgbClr val="6E6E73"/>
@@ -2047,6 +2318,7 @@
           <a:lstStyle xmlns:a="http://schemas.openxmlformats.org/drawingml/2006/main"/>
           <a:p xmlns:a="http://schemas.openxmlformats.org/drawingml/2006/main">
             <a:pPr algn="l">
+              <a:buNone/>
               <a:defRPr sz="2175" b="1">
                 <a:solidFill>
                   <a:srgbClr val="0F766E"/>
@@ -2111,6 +2383,7 @@
           <a:lstStyle xmlns:a="http://schemas.openxmlformats.org/drawingml/2006/main"/>
           <a:p xmlns:a="http://schemas.openxmlformats.org/drawingml/2006/main">
             <a:pPr algn="l">
+              <a:buNone/>
               <a:defRPr sz="900" b="0">
                 <a:solidFill>
                   <a:srgbClr val="6E6E73"/>
@@ -2129,7 +2402,7 @@
                 <a:ea typeface="Aptos"/>
                 <a:cs typeface="Aptos"/>
               </a:rPr>
-              <a:t>annotated spans</a:t>
+              <a:t>provisional span labels</a:t>
             </a:r>
           </a:p>
         </p:txBody>
@@ -2208,6 +2481,7 @@
           <a:lstStyle xmlns:a="http://schemas.openxmlformats.org/drawingml/2006/main"/>
           <a:p xmlns:a="http://schemas.openxmlformats.org/drawingml/2006/main">
             <a:pPr algn="l">
+              <a:buNone/>
               <a:defRPr sz="2175" b="1">
                 <a:solidFill>
                   <a:srgbClr val="0066CC"/>
@@ -2272,6 +2546,7 @@
           <a:lstStyle xmlns:a="http://schemas.openxmlformats.org/drawingml/2006/main"/>
           <a:p xmlns:a="http://schemas.openxmlformats.org/drawingml/2006/main">
             <a:pPr algn="l">
+              <a:buNone/>
               <a:defRPr sz="900" b="0">
                 <a:solidFill>
                   <a:srgbClr val="6E6E73"/>
@@ -2290,7 +2565,7 @@
                 <a:ea typeface="Aptos"/>
                 <a:cs typeface="Aptos"/>
               </a:rPr>
-              <a:t>best test AUPRC</a:t>
+              <a:t>exploratory AUPRC</a:t>
             </a:r>
           </a:p>
         </p:txBody>
@@ -2369,6 +2644,7 @@
           <a:lstStyle xmlns:a="http://schemas.openxmlformats.org/drawingml/2006/main"/>
           <a:p xmlns:a="http://schemas.openxmlformats.org/drawingml/2006/main">
             <a:pPr algn="l">
+              <a:buNone/>
               <a:defRPr sz="2175" b="1">
                 <a:solidFill>
                   <a:srgbClr val="0F766E"/>
@@ -2433,6 +2709,7 @@
           <a:lstStyle xmlns:a="http://schemas.openxmlformats.org/drawingml/2006/main"/>
           <a:p xmlns:a="http://schemas.openxmlformats.org/drawingml/2006/main">
             <a:pPr algn="l">
+              <a:buNone/>
               <a:defRPr sz="900" b="0">
                 <a:solidFill>
                   <a:srgbClr val="6E6E73"/>
@@ -2451,7 +2728,7 @@
                 <a:ea typeface="Aptos"/>
                 <a:cs typeface="Aptos"/>
               </a:rPr>
-              <a:t>best test F1</a:t>
+              <a:t>exploratory F1</a:t>
             </a:r>
           </a:p>
         </p:txBody>
@@ -2530,6 +2807,7 @@
           <a:lstStyle xmlns:a="http://schemas.openxmlformats.org/drawingml/2006/main"/>
           <a:p xmlns:a="http://schemas.openxmlformats.org/drawingml/2006/main">
             <a:pPr algn="l">
+              <a:buNone/>
               <a:defRPr sz="1500" b="1">
                 <a:solidFill>
                   <a:srgbClr val="1D1D1F"/>
@@ -2629,6 +2907,7 @@
           <a:lstStyle xmlns:a="http://schemas.openxmlformats.org/drawingml/2006/main"/>
           <a:p xmlns:a="http://schemas.openxmlformats.org/drawingml/2006/main">
             <a:pPr algn="l">
+              <a:buNone/>
               <a:defRPr sz="1200" b="0">
                 <a:solidFill>
                   <a:srgbClr val="1D1D1F"/>
@@ -2728,6 +3007,7 @@
           <a:lstStyle xmlns:a="http://schemas.openxmlformats.org/drawingml/2006/main"/>
           <a:p xmlns:a="http://schemas.openxmlformats.org/drawingml/2006/main">
             <a:pPr algn="l">
+              <a:buNone/>
               <a:defRPr sz="1200" b="0">
                 <a:solidFill>
                   <a:srgbClr val="1D1D1F"/>
@@ -2746,7 +3026,7 @@
                 <a:ea typeface="Aptos"/>
                 <a:cs typeface="Aptos"/>
               </a:rPr>
-              <a:t>Span-level annotation and token alignment</a:t>
+              <a:t>Span labels and token alignment</a:t>
             </a:r>
           </a:p>
         </p:txBody>
@@ -2827,6 +3107,7 @@
           <a:lstStyle xmlns:a="http://schemas.openxmlformats.org/drawingml/2006/main"/>
           <a:p xmlns:a="http://schemas.openxmlformats.org/drawingml/2006/main">
             <a:pPr algn="l">
+              <a:buNone/>
               <a:defRPr sz="1200" b="0">
                 <a:solidFill>
                   <a:srgbClr val="1D1D1F"/>
@@ -2845,7 +3126,7 @@
                 <a:ea typeface="Aptos"/>
                 <a:cs typeface="Aptos"/>
               </a:rPr>
-              <a:t>Split-safe detector scoring</a:t>
+              <a:t>Dev-threshold scoring</a:t>
             </a:r>
           </a:p>
         </p:txBody>
@@ -2926,6 +3207,7 @@
           <a:lstStyle xmlns:a="http://schemas.openxmlformats.org/drawingml/2006/main"/>
           <a:p xmlns:a="http://schemas.openxmlformats.org/drawingml/2006/main">
             <a:pPr algn="l">
+              <a:buNone/>
               <a:defRPr sz="1200" b="0">
                 <a:solidFill>
                   <a:srgbClr val="1D1D1F"/>
@@ -2990,6 +3272,7 @@
           <a:lstStyle xmlns:a="http://schemas.openxmlformats.org/drawingml/2006/main"/>
           <a:p xmlns:a="http://schemas.openxmlformats.org/drawingml/2006/main">
             <a:pPr algn="l">
+              <a:buNone/>
               <a:defRPr sz="975" b="0">
                 <a:solidFill>
                   <a:srgbClr val="6E6E73"/>
@@ -3044,7 +3327,7 @@
       </p:grpSpPr>
       <p:sp>
         <p:nvSpPr>
-          <p:cNvPr id="1" name="">
+          <p:cNvPr id="38" name="">
             <a:extLst xmlns:a="http://schemas.openxmlformats.org/drawingml/2006/main">
               <a:ext uri="{FF2B5EF4-FFF2-40B4-BE49-F238E27FC236}">
                 <a16:creationId xmlns:a16="http://schemas.microsoft.com/office/drawing/2014/main" id="{8CBACA32-6C72-467F-A90C-5F5E8365903B}"/>
@@ -3083,6 +3366,7 @@
           <a:lstStyle xmlns:a="http://schemas.openxmlformats.org/drawingml/2006/main"/>
           <a:p xmlns:a="http://schemas.openxmlformats.org/drawingml/2006/main">
             <a:pPr algn="l">
+              <a:buNone/>
               <a:defRPr sz="975" b="1">
                 <a:solidFill>
                   <a:srgbClr val="0066CC"/>
@@ -3147,6 +3431,7 @@
           <a:lstStyle xmlns:a="http://schemas.openxmlformats.org/drawingml/2006/main"/>
           <a:p xmlns:a="http://schemas.openxmlformats.org/drawingml/2006/main">
             <a:pPr algn="l">
+              <a:buNone/>
               <a:defRPr sz="2550" b="1">
                 <a:solidFill>
                   <a:srgbClr val="1D1D1F"/>
@@ -3211,6 +3496,7 @@
           <a:lstStyle xmlns:a="http://schemas.openxmlformats.org/drawingml/2006/main"/>
           <a:p xmlns:a="http://schemas.openxmlformats.org/drawingml/2006/main">
             <a:pPr algn="l">
+              <a:buNone/>
               <a:defRPr sz="1275" b="0">
                 <a:solidFill>
                   <a:srgbClr val="6E6E73"/>
@@ -3308,6 +3594,7 @@
           <a:lstStyle xmlns:a="http://schemas.openxmlformats.org/drawingml/2006/main"/>
           <a:p xmlns:a="http://schemas.openxmlformats.org/drawingml/2006/main">
             <a:pPr algn="r">
+              <a:buNone/>
               <a:defRPr sz="900" b="0">
                 <a:solidFill>
                   <a:srgbClr val="6E6E73"/>
@@ -3405,6 +3692,7 @@
           <a:lstStyle xmlns:a="http://schemas.openxmlformats.org/drawingml/2006/main"/>
           <a:p xmlns:a="http://schemas.openxmlformats.org/drawingml/2006/main">
             <a:pPr algn="l">
+              <a:buNone/>
               <a:defRPr sz="1650" b="1">
                 <a:solidFill>
                   <a:srgbClr val="0066CC"/>
@@ -3504,6 +3792,7 @@
           <a:lstStyle xmlns:a="http://schemas.openxmlformats.org/drawingml/2006/main"/>
           <a:p xmlns:a="http://schemas.openxmlformats.org/drawingml/2006/main">
             <a:pPr algn="l">
+              <a:buNone/>
               <a:defRPr sz="1200" b="0">
                 <a:solidFill>
                   <a:srgbClr val="1D1D1F"/>
@@ -3603,6 +3892,7 @@
           <a:lstStyle xmlns:a="http://schemas.openxmlformats.org/drawingml/2006/main"/>
           <a:p xmlns:a="http://schemas.openxmlformats.org/drawingml/2006/main">
             <a:pPr algn="l">
+              <a:buNone/>
               <a:defRPr sz="1200" b="0">
                 <a:solidFill>
                   <a:srgbClr val="1D1D1F"/>
@@ -3702,6 +3992,7 @@
           <a:lstStyle xmlns:a="http://schemas.openxmlformats.org/drawingml/2006/main"/>
           <a:p xmlns:a="http://schemas.openxmlformats.org/drawingml/2006/main">
             <a:pPr algn="l">
+              <a:buNone/>
               <a:defRPr sz="1200" b="0">
                 <a:solidFill>
                   <a:srgbClr val="1D1D1F"/>
@@ -3720,7 +4011,7 @@
                 <a:ea typeface="Aptos"/>
                 <a:cs typeface="Aptos"/>
               </a:rPr>
-              <a:t>JHU BAAI-ready analytics storytelling</a:t>
+              <a:t>JHU MSBAAI analytics storytelling</a:t>
             </a:r>
           </a:p>
         </p:txBody>
@@ -3799,6 +4090,7 @@
           <a:lstStyle xmlns:a="http://schemas.openxmlformats.org/drawingml/2006/main"/>
           <a:p xmlns:a="http://schemas.openxmlformats.org/drawingml/2006/main">
             <a:pPr algn="l">
+              <a:buNone/>
               <a:defRPr sz="1650" b="1">
                 <a:solidFill>
                   <a:srgbClr val="0F766E"/>
@@ -3898,6 +4190,7 @@
           <a:lstStyle xmlns:a="http://schemas.openxmlformats.org/drawingml/2006/main"/>
           <a:p xmlns:a="http://schemas.openxmlformats.org/drawingml/2006/main">
             <a:pPr algn="l">
+              <a:buNone/>
               <a:defRPr sz="1200" b="0">
                 <a:solidFill>
                   <a:srgbClr val="1D1D1F"/>
@@ -3997,6 +4290,7 @@
           <a:lstStyle xmlns:a="http://schemas.openxmlformats.org/drawingml/2006/main"/>
           <a:p xmlns:a="http://schemas.openxmlformats.org/drawingml/2006/main">
             <a:pPr algn="l">
+              <a:buNone/>
               <a:defRPr sz="1200" b="0">
                 <a:solidFill>
                   <a:srgbClr val="1D1D1F"/>
@@ -4096,6 +4390,7 @@
           <a:lstStyle xmlns:a="http://schemas.openxmlformats.org/drawingml/2006/main"/>
           <a:p xmlns:a="http://schemas.openxmlformats.org/drawingml/2006/main">
             <a:pPr algn="l">
+              <a:buNone/>
               <a:defRPr sz="1200" b="0">
                 <a:solidFill>
                   <a:srgbClr val="1D1D1F"/>
@@ -4114,7 +4409,7 @@
                 <a:ea typeface="Aptos"/>
                 <a:cs typeface="Aptos"/>
               </a:rPr>
-              <a:t>Dev/test detector evaluation</a:t>
+              <a:t>Dev-threshold / test comparison</a:t>
             </a:r>
           </a:p>
         </p:txBody>
@@ -4193,6 +4488,7 @@
           <a:lstStyle xmlns:a="http://schemas.openxmlformats.org/drawingml/2006/main"/>
           <a:p xmlns:a="http://schemas.openxmlformats.org/drawingml/2006/main">
             <a:pPr algn="l">
+              <a:buNone/>
               <a:defRPr sz="1650" b="1">
                 <a:solidFill>
                   <a:srgbClr val="B3261E"/>
@@ -4292,6 +4588,7 @@
           <a:lstStyle xmlns:a="http://schemas.openxmlformats.org/drawingml/2006/main"/>
           <a:p xmlns:a="http://schemas.openxmlformats.org/drawingml/2006/main">
             <a:pPr algn="l">
+              <a:buNone/>
               <a:defRPr sz="1200" b="0">
                 <a:solidFill>
                   <a:srgbClr val="1D1D1F"/>
@@ -4310,7 +4607,7 @@
                 <a:ea typeface="Aptos"/>
                 <a:cs typeface="Aptos"/>
               </a:rPr>
-              <a:t>Small benchmark, not a universal detector</a:t>
+              <a:t>Small exploratory study, not a universal detector</a:t>
             </a:r>
           </a:p>
         </p:txBody>
@@ -4391,6 +4688,7 @@
           <a:lstStyle xmlns:a="http://schemas.openxmlformats.org/drawingml/2006/main"/>
           <a:p xmlns:a="http://schemas.openxmlformats.org/drawingml/2006/main">
             <a:pPr algn="l">
+              <a:buNone/>
               <a:defRPr sz="1200" b="0">
                 <a:solidFill>
                   <a:srgbClr val="1D1D1F"/>
@@ -4409,7 +4707,7 @@
                 <a:ea typeface="Aptos"/>
                 <a:cs typeface="Aptos"/>
               </a:rPr>
-              <a:t>Assistant-reviewed labels, not a human benchmark</a:t>
+              <a:t>AI-assisted labels; no human benchmark</a:t>
             </a:r>
           </a:p>
         </p:txBody>
@@ -4490,6 +4788,7 @@
           <a:lstStyle xmlns:a="http://schemas.openxmlformats.org/drawingml/2006/main"/>
           <a:p xmlns:a="http://schemas.openxmlformats.org/drawingml/2006/main">
             <a:pPr algn="l">
+              <a:buNone/>
               <a:defRPr sz="1200" b="0">
                 <a:solidFill>
                   <a:srgbClr val="1D1D1F"/>
@@ -4587,6 +4886,7 @@
           <a:lstStyle xmlns:a="http://schemas.openxmlformats.org/drawingml/2006/main"/>
           <a:p xmlns:a="http://schemas.openxmlformats.org/drawingml/2006/main">
             <a:pPr algn="ctr">
+              <a:buNone/>
               <a:defRPr sz="1088" b="1">
                 <a:solidFill>
                   <a:srgbClr val="0066CC"/>
@@ -4684,6 +4984,7 @@
           <a:lstStyle xmlns:a="http://schemas.openxmlformats.org/drawingml/2006/main"/>
           <a:p xmlns:a="http://schemas.openxmlformats.org/drawingml/2006/main">
             <a:pPr algn="ctr">
+              <a:buNone/>
               <a:defRPr sz="900" b="1">
                 <a:solidFill>
                   <a:srgbClr val="0066CC"/>
@@ -4781,6 +5082,7 @@
           <a:lstStyle xmlns:a="http://schemas.openxmlformats.org/drawingml/2006/main"/>
           <a:p xmlns:a="http://schemas.openxmlformats.org/drawingml/2006/main">
             <a:pPr algn="ctr">
+              <a:buNone/>
               <a:defRPr sz="900" b="1">
                 <a:solidFill>
                   <a:srgbClr val="0F766E"/>
@@ -4878,6 +5180,7 @@
           <a:lstStyle xmlns:a="http://schemas.openxmlformats.org/drawingml/2006/main"/>
           <a:p xmlns:a="http://schemas.openxmlformats.org/drawingml/2006/main">
             <a:pPr algn="ctr">
+              <a:buNone/>
               <a:defRPr sz="900" b="1">
                 <a:solidFill>
                   <a:srgbClr val="9A6700"/>
@@ -4932,7 +5235,7 @@
       </p:grpSpPr>
       <p:sp>
         <p:nvSpPr>
-          <p:cNvPr id="1" name="">
+          <p:cNvPr id="36" name="">
             <a:extLst xmlns:a="http://schemas.openxmlformats.org/drawingml/2006/main">
               <a:ext uri="{FF2B5EF4-FFF2-40B4-BE49-F238E27FC236}">
                 <a16:creationId xmlns:a16="http://schemas.microsoft.com/office/drawing/2014/main" id="{4904731A-3BD4-45F2-A1D8-5FB37D1FF4B2}"/>
@@ -4971,6 +5274,7 @@
           <a:lstStyle xmlns:a="http://schemas.openxmlformats.org/drawingml/2006/main"/>
           <a:p xmlns:a="http://schemas.openxmlformats.org/drawingml/2006/main">
             <a:pPr algn="l">
+              <a:buNone/>
               <a:defRPr sz="975" b="1">
                 <a:solidFill>
                   <a:srgbClr val="0066CC"/>
@@ -5035,6 +5339,7 @@
           <a:lstStyle xmlns:a="http://schemas.openxmlformats.org/drawingml/2006/main"/>
           <a:p xmlns:a="http://schemas.openxmlformats.org/drawingml/2006/main">
             <a:pPr algn="l">
+              <a:buNone/>
               <a:defRPr sz="2550" b="1">
                 <a:solidFill>
                   <a:srgbClr val="1D1D1F"/>
@@ -5099,6 +5404,7 @@
           <a:lstStyle xmlns:a="http://schemas.openxmlformats.org/drawingml/2006/main"/>
           <a:p xmlns:a="http://schemas.openxmlformats.org/drawingml/2006/main">
             <a:pPr algn="l">
+              <a:buNone/>
               <a:defRPr sz="1275" b="0">
                 <a:solidFill>
                   <a:srgbClr val="6E6E73"/>
@@ -5196,6 +5502,7 @@
           <a:lstStyle xmlns:a="http://schemas.openxmlformats.org/drawingml/2006/main"/>
           <a:p xmlns:a="http://schemas.openxmlformats.org/drawingml/2006/main">
             <a:pPr algn="r">
+              <a:buNone/>
               <a:defRPr sz="900" b="0">
                 <a:solidFill>
                   <a:srgbClr val="6E6E73"/>
@@ -5293,6 +5600,7 @@
           <a:lstStyle xmlns:a="http://schemas.openxmlformats.org/drawingml/2006/main"/>
           <a:p xmlns:a="http://schemas.openxmlformats.org/drawingml/2006/main">
             <a:pPr algn="l">
+              <a:buNone/>
               <a:defRPr sz="1500" b="1">
                 <a:solidFill>
                   <a:srgbClr val="0066CC"/>
@@ -5392,6 +5700,7 @@
           <a:lstStyle xmlns:a="http://schemas.openxmlformats.org/drawingml/2006/main"/>
           <a:p xmlns:a="http://schemas.openxmlformats.org/drawingml/2006/main">
             <a:pPr algn="l">
+              <a:buNone/>
               <a:defRPr sz="1200" b="0">
                 <a:solidFill>
                   <a:srgbClr val="1D1D1F"/>
@@ -5491,6 +5800,7 @@
           <a:lstStyle xmlns:a="http://schemas.openxmlformats.org/drawingml/2006/main"/>
           <a:p xmlns:a="http://schemas.openxmlformats.org/drawingml/2006/main">
             <a:pPr algn="l">
+              <a:buNone/>
               <a:defRPr sz="1200" b="0">
                 <a:solidFill>
                   <a:srgbClr val="1D1D1F"/>
@@ -5590,6 +5900,7 @@
           <a:lstStyle xmlns:a="http://schemas.openxmlformats.org/drawingml/2006/main"/>
           <a:p xmlns:a="http://schemas.openxmlformats.org/drawingml/2006/main">
             <a:pPr algn="l">
+              <a:buNone/>
               <a:defRPr sz="1200" b="0">
                 <a:solidFill>
                   <a:srgbClr val="1D1D1F"/>
@@ -5654,6 +5965,7 @@
           <a:lstStyle xmlns:a="http://schemas.openxmlformats.org/drawingml/2006/main"/>
           <a:p xmlns:a="http://schemas.openxmlformats.org/drawingml/2006/main">
             <a:pPr algn="ctr">
+              <a:buNone/>
               <a:defRPr sz="2850" b="1">
                 <a:solidFill>
                   <a:srgbClr val="6E6E73"/>
@@ -5751,6 +6063,7 @@
           <a:lstStyle xmlns:a="http://schemas.openxmlformats.org/drawingml/2006/main"/>
           <a:p xmlns:a="http://schemas.openxmlformats.org/drawingml/2006/main">
             <a:pPr algn="l">
+              <a:buNone/>
               <a:defRPr sz="1500" b="1">
                 <a:solidFill>
                   <a:srgbClr val="1D1D1F"/>
@@ -5850,6 +6163,7 @@
           <a:lstStyle xmlns:a="http://schemas.openxmlformats.org/drawingml/2006/main"/>
           <a:p xmlns:a="http://schemas.openxmlformats.org/drawingml/2006/main">
             <a:pPr algn="l">
+              <a:buNone/>
               <a:defRPr sz="1125" b="0">
                 <a:solidFill>
                   <a:srgbClr val="1D1D1F"/>
@@ -5949,6 +6263,7 @@
           <a:lstStyle xmlns:a="http://schemas.openxmlformats.org/drawingml/2006/main"/>
           <a:p xmlns:a="http://schemas.openxmlformats.org/drawingml/2006/main">
             <a:pPr algn="l">
+              <a:buNone/>
               <a:defRPr sz="1125" b="0">
                 <a:solidFill>
                   <a:srgbClr val="1D1D1F"/>
@@ -6048,6 +6363,7 @@
           <a:lstStyle xmlns:a="http://schemas.openxmlformats.org/drawingml/2006/main"/>
           <a:p xmlns:a="http://schemas.openxmlformats.org/drawingml/2006/main">
             <a:pPr algn="l">
+              <a:buNone/>
               <a:defRPr sz="1125" b="0">
                 <a:solidFill>
                   <a:srgbClr val="1D1D1F"/>
@@ -6147,6 +6463,7 @@
           <a:lstStyle xmlns:a="http://schemas.openxmlformats.org/drawingml/2006/main"/>
           <a:p xmlns:a="http://schemas.openxmlformats.org/drawingml/2006/main">
             <a:pPr algn="l">
+              <a:buNone/>
               <a:defRPr sz="1125" b="0">
                 <a:solidFill>
                   <a:srgbClr val="1D1D1F"/>
@@ -6211,6 +6528,7 @@
           <a:lstStyle xmlns:a="http://schemas.openxmlformats.org/drawingml/2006/main"/>
           <a:p xmlns:a="http://schemas.openxmlformats.org/drawingml/2006/main">
             <a:pPr algn="ctr">
+              <a:buNone/>
               <a:defRPr sz="2850" b="1">
                 <a:solidFill>
                   <a:srgbClr val="6E6E73"/>
@@ -6308,6 +6626,7 @@
           <a:lstStyle xmlns:a="http://schemas.openxmlformats.org/drawingml/2006/main"/>
           <a:p xmlns:a="http://schemas.openxmlformats.org/drawingml/2006/main">
             <a:pPr algn="l">
+              <a:buNone/>
               <a:defRPr sz="1500" b="1">
                 <a:solidFill>
                   <a:srgbClr val="B3261E"/>
@@ -6407,6 +6726,7 @@
           <a:lstStyle xmlns:a="http://schemas.openxmlformats.org/drawingml/2006/main"/>
           <a:p xmlns:a="http://schemas.openxmlformats.org/drawingml/2006/main">
             <a:pPr algn="l">
+              <a:buNone/>
               <a:defRPr sz="1200" b="0">
                 <a:solidFill>
                   <a:srgbClr val="1D1D1F"/>
@@ -6425,7 +6745,7 @@
                 <a:ea typeface="Aptos"/>
                 <a:cs typeface="Aptos"/>
               </a:rPr>
-              <a:t>Bad sourcing decisions</a:t>
+              <a:t>Revenue reconciliation errors</a:t>
             </a:r>
           </a:p>
         </p:txBody>
@@ -6506,6 +6826,7 @@
           <a:lstStyle xmlns:a="http://schemas.openxmlformats.org/drawingml/2006/main"/>
           <a:p xmlns:a="http://schemas.openxmlformats.org/drawingml/2006/main">
             <a:pPr algn="l">
+              <a:buNone/>
               <a:defRPr sz="1200" b="0">
                 <a:solidFill>
                   <a:srgbClr val="1D1D1F"/>
@@ -6524,7 +6845,7 @@
                 <a:ea typeface="Aptos"/>
                 <a:cs typeface="Aptos"/>
               </a:rPr>
-              <a:t>Wrong inventory priorities</a:t>
+              <a:t>Returns-impact errors</a:t>
             </a:r>
           </a:p>
         </p:txBody>
@@ -6605,6 +6926,7 @@
           <a:lstStyle xmlns:a="http://schemas.openxmlformats.org/drawingml/2006/main"/>
           <a:p xmlns:a="http://schemas.openxmlformats.org/drawingml/2006/main">
             <a:pPr algn="l">
+              <a:buNone/>
               <a:defRPr sz="1200" b="0">
                 <a:solidFill>
                   <a:srgbClr val="1D1D1F"/>
@@ -6623,7 +6945,7 @@
                 <a:ea typeface="Aptos"/>
                 <a:cs typeface="Aptos"/>
               </a:rPr>
-              <a:t>Misleading revenue narrative</a:t>
+              <a:t>Misleading product rankings</a:t>
             </a:r>
           </a:p>
         </p:txBody>
@@ -6702,6 +7024,7 @@
           <a:lstStyle xmlns:a="http://schemas.openxmlformats.org/drawingml/2006/main"/>
           <a:p xmlns:a="http://schemas.openxmlformats.org/drawingml/2006/main">
             <a:pPr algn="l">
+              <a:buNone/>
               <a:defRPr sz="1275" b="1">
                 <a:solidFill>
                   <a:srgbClr val="2F3A45"/>
@@ -6756,7 +7079,7 @@
       </p:grpSpPr>
       <p:sp>
         <p:nvSpPr>
-          <p:cNvPr id="1" name="">
+          <p:cNvPr id="40" name="">
             <a:extLst xmlns:a="http://schemas.openxmlformats.org/drawingml/2006/main">
               <a:ext uri="{FF2B5EF4-FFF2-40B4-BE49-F238E27FC236}">
                 <a16:creationId xmlns:a16="http://schemas.microsoft.com/office/drawing/2014/main" id="{39E5E99F-60B4-4D46-93A8-B9CF889405D2}"/>
@@ -6795,6 +7118,7 @@
           <a:lstStyle xmlns:a="http://schemas.openxmlformats.org/drawingml/2006/main"/>
           <a:p xmlns:a="http://schemas.openxmlformats.org/drawingml/2006/main">
             <a:pPr algn="l">
+              <a:buNone/>
               <a:defRPr sz="975" b="1">
                 <a:solidFill>
                   <a:srgbClr val="0066CC"/>
@@ -6859,6 +7183,7 @@
           <a:lstStyle xmlns:a="http://schemas.openxmlformats.org/drawingml/2006/main"/>
           <a:p xmlns:a="http://schemas.openxmlformats.org/drawingml/2006/main">
             <a:pPr algn="l">
+              <a:buNone/>
               <a:defRPr sz="2550" b="1">
                 <a:solidFill>
                   <a:srgbClr val="1D1D1F"/>
@@ -6923,6 +7248,7 @@
           <a:lstStyle xmlns:a="http://schemas.openxmlformats.org/drawingml/2006/main"/>
           <a:p xmlns:a="http://schemas.openxmlformats.org/drawingml/2006/main">
             <a:pPr algn="l">
+              <a:buNone/>
               <a:defRPr sz="1275" b="0">
                 <a:solidFill>
                   <a:srgbClr val="6E6E73"/>
@@ -7020,6 +7346,7 @@
           <a:lstStyle xmlns:a="http://schemas.openxmlformats.org/drawingml/2006/main"/>
           <a:p xmlns:a="http://schemas.openxmlformats.org/drawingml/2006/main">
             <a:pPr algn="r">
+              <a:buNone/>
               <a:defRPr sz="900" b="0">
                 <a:solidFill>
                   <a:srgbClr val="6E6E73"/>
@@ -7150,6 +7477,7 @@
           <a:lstStyle xmlns:a="http://schemas.openxmlformats.org/drawingml/2006/main"/>
           <a:p xmlns:a="http://schemas.openxmlformats.org/drawingml/2006/main">
             <a:pPr algn="l">
+              <a:buNone/>
               <a:defRPr sz="1200" b="1">
                 <a:solidFill>
                   <a:srgbClr val="0066CC"/>
@@ -7214,6 +7542,7 @@
           <a:lstStyle xmlns:a="http://schemas.openxmlformats.org/drawingml/2006/main"/>
           <a:p xmlns:a="http://schemas.openxmlformats.org/drawingml/2006/main">
             <a:pPr algn="l">
+              <a:buNone/>
               <a:defRPr sz="938" b="0">
                 <a:solidFill>
                   <a:srgbClr val="2F3A45"/>
@@ -7344,6 +7673,7 @@
           <a:lstStyle xmlns:a="http://schemas.openxmlformats.org/drawingml/2006/main"/>
           <a:p xmlns:a="http://schemas.openxmlformats.org/drawingml/2006/main">
             <a:pPr algn="l">
+              <a:buNone/>
               <a:defRPr sz="1200" b="1">
                 <a:solidFill>
                   <a:srgbClr val="0F766E"/>
@@ -7408,6 +7738,7 @@
           <a:lstStyle xmlns:a="http://schemas.openxmlformats.org/drawingml/2006/main"/>
           <a:p xmlns:a="http://schemas.openxmlformats.org/drawingml/2006/main">
             <a:pPr algn="l">
+              <a:buNone/>
               <a:defRPr sz="938" b="0">
                 <a:solidFill>
                   <a:srgbClr val="2F3A45"/>
@@ -7538,6 +7869,7 @@
           <a:lstStyle xmlns:a="http://schemas.openxmlformats.org/drawingml/2006/main"/>
           <a:p xmlns:a="http://schemas.openxmlformats.org/drawingml/2006/main">
             <a:pPr algn="l">
+              <a:buNone/>
               <a:defRPr sz="1200" b="1">
                 <a:solidFill>
                   <a:srgbClr val="9A6700"/>
@@ -7602,6 +7934,7 @@
           <a:lstStyle xmlns:a="http://schemas.openxmlformats.org/drawingml/2006/main"/>
           <a:p xmlns:a="http://schemas.openxmlformats.org/drawingml/2006/main">
             <a:pPr algn="l">
+              <a:buNone/>
               <a:defRPr sz="938" b="0">
                 <a:solidFill>
                   <a:srgbClr val="2F3A45"/>
@@ -7732,6 +8065,7 @@
           <a:lstStyle xmlns:a="http://schemas.openxmlformats.org/drawingml/2006/main"/>
           <a:p xmlns:a="http://schemas.openxmlformats.org/drawingml/2006/main">
             <a:pPr algn="l">
+              <a:buNone/>
               <a:defRPr sz="1200" b="1">
                 <a:solidFill>
                   <a:srgbClr val="B3261E"/>
@@ -7796,6 +8130,7 @@
           <a:lstStyle xmlns:a="http://schemas.openxmlformats.org/drawingml/2006/main"/>
           <a:p xmlns:a="http://schemas.openxmlformats.org/drawingml/2006/main">
             <a:pPr algn="l">
+              <a:buNone/>
               <a:defRPr sz="938" b="0">
                 <a:solidFill>
                   <a:srgbClr val="2F3A45"/>
@@ -7926,6 +8261,7 @@
           <a:lstStyle xmlns:a="http://schemas.openxmlformats.org/drawingml/2006/main"/>
           <a:p xmlns:a="http://schemas.openxmlformats.org/drawingml/2006/main">
             <a:pPr algn="l">
+              <a:buNone/>
               <a:defRPr sz="1200" b="1">
                 <a:solidFill>
                   <a:srgbClr val="2F3A45"/>
@@ -7990,6 +8326,7 @@
           <a:lstStyle xmlns:a="http://schemas.openxmlformats.org/drawingml/2006/main"/>
           <a:p xmlns:a="http://schemas.openxmlformats.org/drawingml/2006/main">
             <a:pPr algn="l">
+              <a:buNone/>
               <a:defRPr sz="938" b="0">
                 <a:solidFill>
                   <a:srgbClr val="2F3A45"/>
@@ -8054,6 +8391,7 @@
           <a:lstStyle xmlns:a="http://schemas.openxmlformats.org/drawingml/2006/main"/>
           <a:p xmlns:a="http://schemas.openxmlformats.org/drawingml/2006/main">
             <a:pPr algn="ctr">
+              <a:buNone/>
               <a:defRPr sz="1800" b="1">
                 <a:solidFill>
                   <a:srgbClr val="6E6E73"/>
@@ -8118,6 +8456,7 @@
           <a:lstStyle xmlns:a="http://schemas.openxmlformats.org/drawingml/2006/main"/>
           <a:p xmlns:a="http://schemas.openxmlformats.org/drawingml/2006/main">
             <a:pPr algn="ctr">
+              <a:buNone/>
               <a:defRPr sz="1800" b="1">
                 <a:solidFill>
                   <a:srgbClr val="6E6E73"/>
@@ -8182,6 +8521,7 @@
           <a:lstStyle xmlns:a="http://schemas.openxmlformats.org/drawingml/2006/main"/>
           <a:p xmlns:a="http://schemas.openxmlformats.org/drawingml/2006/main">
             <a:pPr algn="ctr">
+              <a:buNone/>
               <a:defRPr sz="1800" b="1">
                 <a:solidFill>
                   <a:srgbClr val="6E6E73"/>
@@ -8246,6 +8586,7 @@
           <a:lstStyle xmlns:a="http://schemas.openxmlformats.org/drawingml/2006/main"/>
           <a:p xmlns:a="http://schemas.openxmlformats.org/drawingml/2006/main">
             <a:pPr algn="ctr">
+              <a:buNone/>
               <a:defRPr sz="1800" b="1">
                 <a:solidFill>
                   <a:srgbClr val="6E6E73"/>
@@ -8343,6 +8684,7 @@
           <a:lstStyle xmlns:a="http://schemas.openxmlformats.org/drawingml/2006/main"/>
           <a:p xmlns:a="http://schemas.openxmlformats.org/drawingml/2006/main">
             <a:pPr algn="l">
+              <a:buNone/>
               <a:defRPr sz="1500" b="1">
                 <a:solidFill>
                   <a:srgbClr val="0F766E"/>
@@ -8407,6 +8749,7 @@
           <a:lstStyle xmlns:a="http://schemas.openxmlformats.org/drawingml/2006/main"/>
           <a:p xmlns:a="http://schemas.openxmlformats.org/drawingml/2006/main">
             <a:pPr algn="l">
+              <a:buNone/>
               <a:defRPr sz="1200" b="0">
                 <a:solidFill>
                   <a:srgbClr val="2F3A45"/>
@@ -8425,7 +8768,7 @@
                 <a:ea typeface="Aptos"/>
                 <a:cs typeface="Aptos"/>
               </a:rPr>
-              <a:t>Thresholds are selected on dev spans and reused unchanged on test spans. The reported detector metrics are therefore split-safe within this small benchmark.</a:t>
+              <a:t>Thresholds are selected on dev spans and reused on test. The two headline values are exploratory maxima across candidate signals, not confirmation estimates.</a:t>
             </a:r>
           </a:p>
         </p:txBody>
@@ -8504,6 +8847,7 @@
           <a:lstStyle xmlns:a="http://schemas.openxmlformats.org/drawingml/2006/main"/>
           <a:p xmlns:a="http://schemas.openxmlformats.org/drawingml/2006/main">
             <a:pPr algn="l">
+              <a:buNone/>
               <a:defRPr sz="1500" b="1">
                 <a:solidFill>
                   <a:srgbClr val="9A6700"/>
@@ -8601,6 +8945,7 @@
           <a:lstStyle xmlns:a="http://schemas.openxmlformats.org/drawingml/2006/main"/>
           <a:p xmlns:a="http://schemas.openxmlformats.org/drawingml/2006/main">
             <a:pPr algn="ctr">
+              <a:buNone/>
               <a:defRPr sz="900" b="1">
                 <a:solidFill>
                   <a:srgbClr val="0066CC"/>
@@ -8698,6 +9043,7 @@
           <a:lstStyle xmlns:a="http://schemas.openxmlformats.org/drawingml/2006/main"/>
           <a:p xmlns:a="http://schemas.openxmlformats.org/drawingml/2006/main">
             <a:pPr algn="ctr">
+              <a:buNone/>
               <a:defRPr sz="900" b="1">
                 <a:solidFill>
                   <a:srgbClr val="9A6700"/>
@@ -8762,6 +9108,7 @@
           <a:lstStyle xmlns:a="http://schemas.openxmlformats.org/drawingml/2006/main"/>
           <a:p xmlns:a="http://schemas.openxmlformats.org/drawingml/2006/main">
             <a:pPr algn="l">
+              <a:buNone/>
               <a:defRPr sz="825" b="0">
                 <a:solidFill>
                   <a:srgbClr val="6E6E73"/>
@@ -8816,7 +9163,7 @@
       </p:grpSpPr>
       <p:sp>
         <p:nvSpPr>
-          <p:cNvPr id="1" name="">
+          <p:cNvPr id="44" name="">
             <a:extLst xmlns:a="http://schemas.openxmlformats.org/drawingml/2006/main">
               <a:ext uri="{FF2B5EF4-FFF2-40B4-BE49-F238E27FC236}">
                 <a16:creationId xmlns:a16="http://schemas.microsoft.com/office/drawing/2014/main" id="{8389A0F8-E36F-47B0-B277-B38E87A4F65B}"/>
@@ -8855,6 +9202,7 @@
           <a:lstStyle xmlns:a="http://schemas.openxmlformats.org/drawingml/2006/main"/>
           <a:p xmlns:a="http://schemas.openxmlformats.org/drawingml/2006/main">
             <a:pPr algn="l">
+              <a:buNone/>
               <a:defRPr sz="975" b="1">
                 <a:solidFill>
                   <a:srgbClr val="0066CC"/>
@@ -8919,6 +9267,7 @@
           <a:lstStyle xmlns:a="http://schemas.openxmlformats.org/drawingml/2006/main"/>
           <a:p xmlns:a="http://schemas.openxmlformats.org/drawingml/2006/main">
             <a:pPr algn="l">
+              <a:buNone/>
               <a:defRPr sz="2550" b="1">
                 <a:solidFill>
                   <a:srgbClr val="1D1D1F"/>
@@ -8983,6 +9332,7 @@
           <a:lstStyle xmlns:a="http://schemas.openxmlformats.org/drawingml/2006/main"/>
           <a:p xmlns:a="http://schemas.openxmlformats.org/drawingml/2006/main">
             <a:pPr algn="l">
+              <a:buNone/>
               <a:defRPr sz="1275" b="0">
                 <a:solidFill>
                   <a:srgbClr val="6E6E73"/>
@@ -9080,6 +9430,7 @@
           <a:lstStyle xmlns:a="http://schemas.openxmlformats.org/drawingml/2006/main"/>
           <a:p xmlns:a="http://schemas.openxmlformats.org/drawingml/2006/main">
             <a:pPr algn="r">
+              <a:buNone/>
               <a:defRPr sz="900" b="0">
                 <a:solidFill>
                   <a:srgbClr val="6E6E73"/>
@@ -9177,6 +9528,7 @@
           <a:lstStyle xmlns:a="http://schemas.openxmlformats.org/drawingml/2006/main"/>
           <a:p xmlns:a="http://schemas.openxmlformats.org/drawingml/2006/main">
             <a:pPr algn="l">
+              <a:buNone/>
               <a:defRPr sz="2175" b="1">
                 <a:solidFill>
                   <a:srgbClr val="0066CC"/>
@@ -9241,6 +9593,7 @@
           <a:lstStyle xmlns:a="http://schemas.openxmlformats.org/drawingml/2006/main"/>
           <a:p xmlns:a="http://schemas.openxmlformats.org/drawingml/2006/main">
             <a:pPr algn="l">
+              <a:buNone/>
               <a:defRPr sz="900" b="0">
                 <a:solidFill>
                   <a:srgbClr val="6E6E73"/>
@@ -9338,6 +9691,7 @@
           <a:lstStyle xmlns:a="http://schemas.openxmlformats.org/drawingml/2006/main"/>
           <a:p xmlns:a="http://schemas.openxmlformats.org/drawingml/2006/main">
             <a:pPr algn="l">
+              <a:buNone/>
               <a:defRPr sz="2175" b="1">
                 <a:solidFill>
                   <a:srgbClr val="0F766E"/>
@@ -9402,6 +9756,7 @@
           <a:lstStyle xmlns:a="http://schemas.openxmlformats.org/drawingml/2006/main"/>
           <a:p xmlns:a="http://schemas.openxmlformats.org/drawingml/2006/main">
             <a:pPr algn="l">
+              <a:buNone/>
               <a:defRPr sz="900" b="0">
                 <a:solidFill>
                   <a:srgbClr val="6E6E73"/>
@@ -9499,6 +9854,7 @@
           <a:lstStyle xmlns:a="http://schemas.openxmlformats.org/drawingml/2006/main"/>
           <a:p xmlns:a="http://schemas.openxmlformats.org/drawingml/2006/main">
             <a:pPr algn="l">
+              <a:buNone/>
               <a:defRPr sz="2175" b="1">
                 <a:solidFill>
                   <a:srgbClr val="9A6700"/>
@@ -9563,6 +9919,7 @@
           <a:lstStyle xmlns:a="http://schemas.openxmlformats.org/drawingml/2006/main"/>
           <a:p xmlns:a="http://schemas.openxmlformats.org/drawingml/2006/main">
             <a:pPr algn="l">
+              <a:buNone/>
               <a:defRPr sz="900" b="0">
                 <a:solidFill>
                   <a:srgbClr val="6E6E73"/>
@@ -9660,6 +10017,7 @@
           <a:lstStyle xmlns:a="http://schemas.openxmlformats.org/drawingml/2006/main"/>
           <a:p xmlns:a="http://schemas.openxmlformats.org/drawingml/2006/main">
             <a:pPr algn="l">
+              <a:buNone/>
               <a:defRPr sz="2175" b="1">
                 <a:solidFill>
                   <a:srgbClr val="0066CC"/>
@@ -9724,6 +10082,7 @@
           <a:lstStyle xmlns:a="http://schemas.openxmlformats.org/drawingml/2006/main"/>
           <a:p xmlns:a="http://schemas.openxmlformats.org/drawingml/2006/main">
             <a:pPr algn="l">
+              <a:buNone/>
               <a:defRPr sz="900" b="0">
                 <a:solidFill>
                   <a:srgbClr val="6E6E73"/>
@@ -9821,6 +10180,7 @@
           <a:lstStyle xmlns:a="http://schemas.openxmlformats.org/drawingml/2006/main"/>
           <a:p xmlns:a="http://schemas.openxmlformats.org/drawingml/2006/main">
             <a:pPr algn="l">
+              <a:buNone/>
               <a:defRPr sz="2175" b="1">
                 <a:solidFill>
                   <a:srgbClr val="B3261E"/>
@@ -9885,6 +10245,7 @@
           <a:lstStyle xmlns:a="http://schemas.openxmlformats.org/drawingml/2006/main"/>
           <a:p xmlns:a="http://schemas.openxmlformats.org/drawingml/2006/main">
             <a:pPr algn="l">
+              <a:buNone/>
               <a:defRPr sz="900" b="0">
                 <a:solidFill>
                   <a:srgbClr val="6E6E73"/>
@@ -9949,6 +10310,7 @@
           <a:lstStyle xmlns:a="http://schemas.openxmlformats.org/drawingml/2006/main"/>
           <a:p xmlns:a="http://schemas.openxmlformats.org/drawingml/2006/main">
             <a:pPr algn="l">
+              <a:buNone/>
               <a:defRPr sz="1575" b="1">
                 <a:solidFill>
                   <a:srgbClr val="1D1D1F"/>
@@ -10046,6 +10408,7 @@
           <a:lstStyle xmlns:a="http://schemas.openxmlformats.org/drawingml/2006/main"/>
           <a:p xmlns:a="http://schemas.openxmlformats.org/drawingml/2006/main">
             <a:pPr algn="l">
+              <a:buNone/>
               <a:defRPr sz="975" b="1">
                 <a:solidFill>
                   <a:srgbClr val="2F3A45"/>
@@ -10110,6 +10473,7 @@
           <a:lstStyle xmlns:a="http://schemas.openxmlformats.org/drawingml/2006/main"/>
           <a:p xmlns:a="http://schemas.openxmlformats.org/drawingml/2006/main">
             <a:pPr algn="l">
+              <a:buNone/>
               <a:defRPr sz="975" b="0">
                 <a:solidFill>
                   <a:srgbClr val="2F3A45"/>
@@ -10174,6 +10538,7 @@
           <a:lstStyle xmlns:a="http://schemas.openxmlformats.org/drawingml/2006/main"/>
           <a:p xmlns:a="http://schemas.openxmlformats.org/drawingml/2006/main">
             <a:pPr algn="l">
+              <a:buNone/>
               <a:defRPr sz="975" b="0">
                 <a:solidFill>
                   <a:srgbClr val="2F3A45"/>
@@ -10271,6 +10636,7 @@
           <a:lstStyle xmlns:a="http://schemas.openxmlformats.org/drawingml/2006/main"/>
           <a:p xmlns:a="http://schemas.openxmlformats.org/drawingml/2006/main">
             <a:pPr algn="l">
+              <a:buNone/>
               <a:defRPr sz="975" b="1">
                 <a:solidFill>
                   <a:srgbClr val="2F3A45"/>
@@ -10335,6 +10701,7 @@
           <a:lstStyle xmlns:a="http://schemas.openxmlformats.org/drawingml/2006/main"/>
           <a:p xmlns:a="http://schemas.openxmlformats.org/drawingml/2006/main">
             <a:pPr algn="l">
+              <a:buNone/>
               <a:defRPr sz="975" b="0">
                 <a:solidFill>
                   <a:srgbClr val="2F3A45"/>
@@ -10399,6 +10766,7 @@
           <a:lstStyle xmlns:a="http://schemas.openxmlformats.org/drawingml/2006/main"/>
           <a:p xmlns:a="http://schemas.openxmlformats.org/drawingml/2006/main">
             <a:pPr algn="l">
+              <a:buNone/>
               <a:defRPr sz="975" b="0">
                 <a:solidFill>
                   <a:srgbClr val="2F3A45"/>
@@ -10496,6 +10864,7 @@
           <a:lstStyle xmlns:a="http://schemas.openxmlformats.org/drawingml/2006/main"/>
           <a:p xmlns:a="http://schemas.openxmlformats.org/drawingml/2006/main">
             <a:pPr algn="l">
+              <a:buNone/>
               <a:defRPr sz="975" b="1">
                 <a:solidFill>
                   <a:srgbClr val="2F3A45"/>
@@ -10560,6 +10929,7 @@
           <a:lstStyle xmlns:a="http://schemas.openxmlformats.org/drawingml/2006/main"/>
           <a:p xmlns:a="http://schemas.openxmlformats.org/drawingml/2006/main">
             <a:pPr algn="l">
+              <a:buNone/>
               <a:defRPr sz="975" b="0">
                 <a:solidFill>
                   <a:srgbClr val="2F3A45"/>
@@ -10624,6 +10994,7 @@
           <a:lstStyle xmlns:a="http://schemas.openxmlformats.org/drawingml/2006/main"/>
           <a:p xmlns:a="http://schemas.openxmlformats.org/drawingml/2006/main">
             <a:pPr algn="l">
+              <a:buNone/>
               <a:defRPr sz="975" b="0">
                 <a:solidFill>
                   <a:srgbClr val="2F3A45"/>
@@ -10721,6 +11092,7 @@
           <a:lstStyle xmlns:a="http://schemas.openxmlformats.org/drawingml/2006/main"/>
           <a:p xmlns:a="http://schemas.openxmlformats.org/drawingml/2006/main">
             <a:pPr algn="l">
+              <a:buNone/>
               <a:defRPr sz="975" b="1">
                 <a:solidFill>
                   <a:srgbClr val="2F3A45"/>
@@ -10785,6 +11157,7 @@
           <a:lstStyle xmlns:a="http://schemas.openxmlformats.org/drawingml/2006/main"/>
           <a:p xmlns:a="http://schemas.openxmlformats.org/drawingml/2006/main">
             <a:pPr algn="l">
+              <a:buNone/>
               <a:defRPr sz="975" b="0">
                 <a:solidFill>
                   <a:srgbClr val="2F3A45"/>
@@ -10849,6 +11222,7 @@
           <a:lstStyle xmlns:a="http://schemas.openxmlformats.org/drawingml/2006/main"/>
           <a:p xmlns:a="http://schemas.openxmlformats.org/drawingml/2006/main">
             <a:pPr algn="l">
+              <a:buNone/>
               <a:defRPr sz="975" b="0">
                 <a:solidFill>
                   <a:srgbClr val="2F3A45"/>
@@ -10946,6 +11320,7 @@
           <a:lstStyle xmlns:a="http://schemas.openxmlformats.org/drawingml/2006/main"/>
           <a:p xmlns:a="http://schemas.openxmlformats.org/drawingml/2006/main">
             <a:pPr algn="l">
+              <a:buNone/>
               <a:defRPr sz="975" b="1">
                 <a:solidFill>
                   <a:srgbClr val="2F3A45"/>
@@ -11010,6 +11385,7 @@
           <a:lstStyle xmlns:a="http://schemas.openxmlformats.org/drawingml/2006/main"/>
           <a:p xmlns:a="http://schemas.openxmlformats.org/drawingml/2006/main">
             <a:pPr algn="l">
+              <a:buNone/>
               <a:defRPr sz="975" b="0">
                 <a:solidFill>
                   <a:srgbClr val="2F3A45"/>
@@ -11074,6 +11450,7 @@
           <a:lstStyle xmlns:a="http://schemas.openxmlformats.org/drawingml/2006/main"/>
           <a:p xmlns:a="http://schemas.openxmlformats.org/drawingml/2006/main">
             <a:pPr algn="l">
+              <a:buNone/>
               <a:defRPr sz="975" b="0">
                 <a:solidFill>
                   <a:srgbClr val="2F3A45"/>
@@ -11171,6 +11548,7 @@
           <a:lstStyle xmlns:a="http://schemas.openxmlformats.org/drawingml/2006/main"/>
           <a:p xmlns:a="http://schemas.openxmlformats.org/drawingml/2006/main">
             <a:pPr algn="l">
+              <a:buNone/>
               <a:defRPr sz="1050" b="1">
                 <a:solidFill>
                   <a:srgbClr val="2F3A45"/>
@@ -11225,7 +11603,7 @@
       </p:grpSpPr>
       <p:sp>
         <p:nvSpPr>
-          <p:cNvPr id="1" name="">
+          <p:cNvPr id="36" name="">
             <a:extLst xmlns:a="http://schemas.openxmlformats.org/drawingml/2006/main">
               <a:ext uri="{FF2B5EF4-FFF2-40B4-BE49-F238E27FC236}">
                 <a16:creationId xmlns:a16="http://schemas.microsoft.com/office/drawing/2014/main" id="{2F03EABD-A456-4E23-8C91-7D6443E49723}"/>
@@ -11264,6 +11642,7 @@
           <a:lstStyle xmlns:a="http://schemas.openxmlformats.org/drawingml/2006/main"/>
           <a:p xmlns:a="http://schemas.openxmlformats.org/drawingml/2006/main">
             <a:pPr algn="l">
+              <a:buNone/>
               <a:defRPr sz="975" b="1">
                 <a:solidFill>
                   <a:srgbClr val="0066CC"/>
@@ -11328,6 +11707,7 @@
           <a:lstStyle xmlns:a="http://schemas.openxmlformats.org/drawingml/2006/main"/>
           <a:p xmlns:a="http://schemas.openxmlformats.org/drawingml/2006/main">
             <a:pPr algn="l">
+              <a:buNone/>
               <a:defRPr sz="2550" b="1">
                 <a:solidFill>
                   <a:srgbClr val="1D1D1F"/>
@@ -11346,7 +11726,7 @@
                 <a:ea typeface="Aptos Display"/>
                 <a:cs typeface="Aptos Display"/>
               </a:rPr>
-              <a:t>Labels focus on held-out high-risk business facts</a:t>
+              <a:t>Labels focus on high-risk dev/test business facts</a:t>
             </a:r>
           </a:p>
         </p:txBody>
@@ -11392,6 +11772,7 @@
           <a:lstStyle xmlns:a="http://schemas.openxmlformats.org/drawingml/2006/main"/>
           <a:p xmlns:a="http://schemas.openxmlformats.org/drawingml/2006/main">
             <a:pPr algn="l">
+              <a:buNone/>
               <a:defRPr sz="1275" b="0">
                 <a:solidFill>
                   <a:srgbClr val="6E6E73"/>
@@ -11489,6 +11870,7 @@
           <a:lstStyle xmlns:a="http://schemas.openxmlformats.org/drawingml/2006/main"/>
           <a:p xmlns:a="http://schemas.openxmlformats.org/drawingml/2006/main">
             <a:pPr algn="r">
+              <a:buNone/>
               <a:defRPr sz="900" b="0">
                 <a:solidFill>
                   <a:srgbClr val="6E6E73"/>
@@ -11586,6 +11968,7 @@
           <a:lstStyle xmlns:a="http://schemas.openxmlformats.org/drawingml/2006/main"/>
           <a:p xmlns:a="http://schemas.openxmlformats.org/drawingml/2006/main">
             <a:pPr algn="l">
+              <a:buNone/>
               <a:defRPr sz="2175" b="1">
                 <a:solidFill>
                   <a:srgbClr val="0066CC"/>
@@ -11650,6 +12033,7 @@
           <a:lstStyle xmlns:a="http://schemas.openxmlformats.org/drawingml/2006/main"/>
           <a:p xmlns:a="http://schemas.openxmlformats.org/drawingml/2006/main">
             <a:pPr algn="l">
+              <a:buNone/>
               <a:defRPr sz="900" b="0">
                 <a:solidFill>
                   <a:srgbClr val="6E6E73"/>
@@ -11668,7 +12052,7 @@
                 <a:ea typeface="Aptos"/>
                 <a:cs typeface="Aptos"/>
               </a:rPr>
-              <a:t>held-out dev/test questions</a:t>
+              <a:t>selected dev/test questions</a:t>
             </a:r>
           </a:p>
         </p:txBody>
@@ -11747,6 +12131,7 @@
           <a:lstStyle xmlns:a="http://schemas.openxmlformats.org/drawingml/2006/main"/>
           <a:p xmlns:a="http://schemas.openxmlformats.org/drawingml/2006/main">
             <a:pPr algn="l">
+              <a:buNone/>
               <a:defRPr sz="2175" b="1">
                 <a:solidFill>
                   <a:srgbClr val="0F766E"/>
@@ -11811,6 +12196,7 @@
           <a:lstStyle xmlns:a="http://schemas.openxmlformats.org/drawingml/2006/main"/>
           <a:p xmlns:a="http://schemas.openxmlformats.org/drawingml/2006/main">
             <a:pPr algn="l">
+              <a:buNone/>
               <a:defRPr sz="900" b="0">
                 <a:solidFill>
                   <a:srgbClr val="6E6E73"/>
@@ -11829,7 +12215,7 @@
                 <a:ea typeface="Aptos"/>
                 <a:cs typeface="Aptos"/>
               </a:rPr>
-              <a:t>aligned span labels</a:t>
+              <a:t>provisional span labels</a:t>
             </a:r>
           </a:p>
         </p:txBody>
@@ -11908,6 +12294,7 @@
           <a:lstStyle xmlns:a="http://schemas.openxmlformats.org/drawingml/2006/main"/>
           <a:p xmlns:a="http://schemas.openxmlformats.org/drawingml/2006/main">
             <a:pPr algn="l">
+              <a:buNone/>
               <a:defRPr sz="2175" b="1">
                 <a:solidFill>
                   <a:srgbClr val="9A6700"/>
@@ -11972,6 +12359,7 @@
           <a:lstStyle xmlns:a="http://schemas.openxmlformats.org/drawingml/2006/main"/>
           <a:p xmlns:a="http://schemas.openxmlformats.org/drawingml/2006/main">
             <a:pPr algn="l">
+              <a:buNone/>
               <a:defRPr sz="900" b="0">
                 <a:solidFill>
                   <a:srgbClr val="6E6E73"/>
@@ -12069,6 +12457,7 @@
           <a:lstStyle xmlns:a="http://schemas.openxmlformats.org/drawingml/2006/main"/>
           <a:p xmlns:a="http://schemas.openxmlformats.org/drawingml/2006/main">
             <a:pPr algn="l">
+              <a:buNone/>
               <a:defRPr sz="2175" b="1">
                 <a:solidFill>
                   <a:srgbClr val="B3261E"/>
@@ -12133,6 +12522,7 @@
           <a:lstStyle xmlns:a="http://schemas.openxmlformats.org/drawingml/2006/main"/>
           <a:p xmlns:a="http://schemas.openxmlformats.org/drawingml/2006/main">
             <a:pPr algn="l">
+              <a:buNone/>
               <a:defRPr sz="900" b="0">
                 <a:solidFill>
                   <a:srgbClr val="6E6E73"/>
@@ -12230,6 +12620,7 @@
           <a:lstStyle xmlns:a="http://schemas.openxmlformats.org/drawingml/2006/main"/>
           <a:p xmlns:a="http://schemas.openxmlformats.org/drawingml/2006/main">
             <a:pPr algn="l">
+              <a:buNone/>
               <a:defRPr sz="2175" b="1">
                 <a:solidFill>
                   <a:srgbClr val="2F3A45"/>
@@ -12294,6 +12685,7 @@
           <a:lstStyle xmlns:a="http://schemas.openxmlformats.org/drawingml/2006/main"/>
           <a:p xmlns:a="http://schemas.openxmlformats.org/drawingml/2006/main">
             <a:pPr algn="l">
+              <a:buNone/>
               <a:defRPr sz="900" b="0">
                 <a:solidFill>
                   <a:srgbClr val="6E6E73"/>
@@ -12391,6 +12783,7 @@
           <a:lstStyle xmlns:a="http://schemas.openxmlformats.org/drawingml/2006/main"/>
           <a:p xmlns:a="http://schemas.openxmlformats.org/drawingml/2006/main">
             <a:pPr algn="l">
+              <a:buNone/>
               <a:defRPr sz="1575" b="1">
                 <a:solidFill>
                   <a:srgbClr val="1D1D1F"/>
@@ -12490,6 +12883,7 @@
           <a:lstStyle xmlns:a="http://schemas.openxmlformats.org/drawingml/2006/main"/>
           <a:p xmlns:a="http://schemas.openxmlformats.org/drawingml/2006/main">
             <a:pPr algn="l">
+              <a:buNone/>
               <a:defRPr sz="1125" b="0">
                 <a:solidFill>
                   <a:srgbClr val="1D1D1F"/>
@@ -12589,6 +12983,7 @@
           <a:lstStyle xmlns:a="http://schemas.openxmlformats.org/drawingml/2006/main"/>
           <a:p xmlns:a="http://schemas.openxmlformats.org/drawingml/2006/main">
             <a:pPr algn="l">
+              <a:buNone/>
               <a:defRPr sz="1125" b="0">
                 <a:solidFill>
                   <a:srgbClr val="1D1D1F"/>
@@ -12688,6 +13083,7 @@
           <a:lstStyle xmlns:a="http://schemas.openxmlformats.org/drawingml/2006/main"/>
           <a:p xmlns:a="http://schemas.openxmlformats.org/drawingml/2006/main">
             <a:pPr algn="l">
+              <a:buNone/>
               <a:defRPr sz="1125" b="0">
                 <a:solidFill>
                   <a:srgbClr val="1D1D1F"/>
@@ -12787,6 +13183,7 @@
           <a:lstStyle xmlns:a="http://schemas.openxmlformats.org/drawingml/2006/main"/>
           <a:p xmlns:a="http://schemas.openxmlformats.org/drawingml/2006/main">
             <a:pPr algn="l">
+              <a:buNone/>
               <a:defRPr sz="1125" b="0">
                 <a:solidFill>
                   <a:srgbClr val="1D1D1F"/>
@@ -12884,6 +13281,7 @@
           <a:lstStyle xmlns:a="http://schemas.openxmlformats.org/drawingml/2006/main"/>
           <a:p xmlns:a="http://schemas.openxmlformats.org/drawingml/2006/main">
             <a:pPr algn="l">
+              <a:buNone/>
               <a:defRPr sz="1575" b="1">
                 <a:solidFill>
                   <a:srgbClr val="B3261E"/>
@@ -12948,6 +13346,7 @@
           <a:lstStyle xmlns:a="http://schemas.openxmlformats.org/drawingml/2006/main"/>
           <a:p xmlns:a="http://schemas.openxmlformats.org/drawingml/2006/main">
             <a:pPr algn="l">
+              <a:buNone/>
               <a:defRPr sz="1275" b="0">
                 <a:solidFill>
                   <a:srgbClr val="2F3A45"/>
@@ -13045,6 +13444,7 @@
           <a:lstStyle xmlns:a="http://schemas.openxmlformats.org/drawingml/2006/main"/>
           <a:p xmlns:a="http://schemas.openxmlformats.org/drawingml/2006/main">
             <a:pPr algn="ctr">
+              <a:buNone/>
               <a:defRPr sz="1050" b="1">
                 <a:solidFill>
                   <a:srgbClr val="0F766E"/>
@@ -13063,7 +13463,7 @@
                 <a:ea typeface="Aptos"/>
                 <a:cs typeface="Aptos"/>
               </a:rPr>
-              <a:t>Label status: presentation labels locked after assistant_full_review; no human benchmark claim is made.</a:t>
+              <a:t>Labels: 205 AI-assisted provisional spans; 15 selected spans received added assistant review. No human benchmark.</a:t>
             </a:r>
           </a:p>
         </p:txBody>
@@ -13099,7 +13499,7 @@
       </p:grpSpPr>
       <p:sp>
         <p:nvSpPr>
-          <p:cNvPr id="1" name="">
+          <p:cNvPr id="45" name="">
             <a:extLst xmlns:a="http://schemas.openxmlformats.org/drawingml/2006/main">
               <a:ext uri="{FF2B5EF4-FFF2-40B4-BE49-F238E27FC236}">
                 <a16:creationId xmlns:a16="http://schemas.microsoft.com/office/drawing/2014/main" id="{CDB0D98F-28DF-41BD-B066-5F254C09293B}"/>
@@ -13138,6 +13538,7 @@
           <a:lstStyle xmlns:a="http://schemas.openxmlformats.org/drawingml/2006/main"/>
           <a:p xmlns:a="http://schemas.openxmlformats.org/drawingml/2006/main">
             <a:pPr algn="l">
+              <a:buNone/>
               <a:defRPr sz="975" b="1">
                 <a:solidFill>
                   <a:srgbClr val="0066CC"/>
@@ -13202,6 +13603,7 @@
           <a:lstStyle xmlns:a="http://schemas.openxmlformats.org/drawingml/2006/main"/>
           <a:p xmlns:a="http://schemas.openxmlformats.org/drawingml/2006/main">
             <a:pPr algn="l">
+              <a:buNone/>
               <a:defRPr sz="2550" b="1">
                 <a:solidFill>
                   <a:srgbClr val="1D1D1F"/>
@@ -13220,7 +13622,7 @@
                 <a:ea typeface="Aptos Display"/>
                 <a:cs typeface="Aptos Display"/>
               </a:rPr>
-              <a:t>Simple uncertainty wins, but the margin is narrow</a:t>
+              <a:t>Simple uncertainty leads this exploratory comparison</a:t>
             </a:r>
           </a:p>
         </p:txBody>
@@ -13266,6 +13668,7 @@
           <a:lstStyle xmlns:a="http://schemas.openxmlformats.org/drawingml/2006/main"/>
           <a:p xmlns:a="http://schemas.openxmlformats.org/drawingml/2006/main">
             <a:pPr algn="l">
+              <a:buNone/>
               <a:defRPr sz="1275" b="0">
                 <a:solidFill>
                   <a:srgbClr val="6E6E73"/>
@@ -13284,7 +13687,7 @@
                 <a:ea typeface="Aptos"/>
                 <a:cs typeface="Aptos"/>
               </a:rPr>
-              <a:t>The strongest result is ranking hallucinated spans with top-2 margin; the best F1 comes from mean token entropy.</a:t>
+              <a:t>Top-2 margin has the highest observed test AUPRC; mean token entropy has the highest observed test F1.</a:t>
             </a:r>
           </a:p>
         </p:txBody>
@@ -13363,6 +13766,7 @@
           <a:lstStyle xmlns:a="http://schemas.openxmlformats.org/drawingml/2006/main"/>
           <a:p xmlns:a="http://schemas.openxmlformats.org/drawingml/2006/main">
             <a:pPr algn="r">
+              <a:buNone/>
               <a:defRPr sz="900" b="0">
                 <a:solidFill>
                   <a:srgbClr val="6E6E73"/>
@@ -13460,6 +13864,7 @@
           <a:lstStyle xmlns:a="http://schemas.openxmlformats.org/drawingml/2006/main"/>
           <a:p xmlns:a="http://schemas.openxmlformats.org/drawingml/2006/main">
             <a:pPr algn="l">
+              <a:buNone/>
               <a:defRPr sz="1575" b="1">
                 <a:solidFill>
                   <a:srgbClr val="1D1D1F"/>
@@ -13478,7 +13883,7 @@
                 <a:ea typeface="Aptos"/>
                 <a:cs typeface="Aptos"/>
               </a:rPr>
-              <a:t>Ranking quality (test AUPRC)</a:t>
+              <a:t>Exploratory test AUPRC</a:t>
             </a:r>
           </a:p>
         </p:txBody>
@@ -13524,6 +13929,7 @@
           <a:lstStyle xmlns:a="http://schemas.openxmlformats.org/drawingml/2006/main"/>
           <a:p xmlns:a="http://schemas.openxmlformats.org/drawingml/2006/main">
             <a:pPr algn="l">
+              <a:buNone/>
               <a:defRPr sz="1125" b="0">
                 <a:solidFill>
                   <a:srgbClr val="1D1D1F"/>
@@ -13658,6 +14064,7 @@
           <a:lstStyle xmlns:a="http://schemas.openxmlformats.org/drawingml/2006/main"/>
           <a:p xmlns:a="http://schemas.openxmlformats.org/drawingml/2006/main">
             <a:pPr algn="r">
+              <a:buNone/>
               <a:defRPr sz="1050" b="0">
                 <a:solidFill>
                   <a:srgbClr val="6E6E73"/>
@@ -13722,6 +14129,7 @@
           <a:lstStyle xmlns:a="http://schemas.openxmlformats.org/drawingml/2006/main"/>
           <a:p xmlns:a="http://schemas.openxmlformats.org/drawingml/2006/main">
             <a:pPr algn="l">
+              <a:buNone/>
               <a:defRPr sz="1125" b="0">
                 <a:solidFill>
                   <a:srgbClr val="1D1D1F"/>
@@ -13856,6 +14264,7 @@
           <a:lstStyle xmlns:a="http://schemas.openxmlformats.org/drawingml/2006/main"/>
           <a:p xmlns:a="http://schemas.openxmlformats.org/drawingml/2006/main">
             <a:pPr algn="r">
+              <a:buNone/>
               <a:defRPr sz="1050" b="0">
                 <a:solidFill>
                   <a:srgbClr val="6E6E73"/>
@@ -13920,6 +14329,7 @@
           <a:lstStyle xmlns:a="http://schemas.openxmlformats.org/drawingml/2006/main"/>
           <a:p xmlns:a="http://schemas.openxmlformats.org/drawingml/2006/main">
             <a:pPr algn="l">
+              <a:buNone/>
               <a:defRPr sz="1125" b="0">
                 <a:solidFill>
                   <a:srgbClr val="1D1D1F"/>
@@ -14054,6 +14464,7 @@
           <a:lstStyle xmlns:a="http://schemas.openxmlformats.org/drawingml/2006/main"/>
           <a:p xmlns:a="http://schemas.openxmlformats.org/drawingml/2006/main">
             <a:pPr algn="r">
+              <a:buNone/>
               <a:defRPr sz="1050" b="0">
                 <a:solidFill>
                   <a:srgbClr val="6E6E73"/>
@@ -14118,6 +14529,7 @@
           <a:lstStyle xmlns:a="http://schemas.openxmlformats.org/drawingml/2006/main"/>
           <a:p xmlns:a="http://schemas.openxmlformats.org/drawingml/2006/main">
             <a:pPr algn="l">
+              <a:buNone/>
               <a:defRPr sz="1125" b="0">
                 <a:solidFill>
                   <a:srgbClr val="1D1D1F"/>
@@ -14252,6 +14664,7 @@
           <a:lstStyle xmlns:a="http://schemas.openxmlformats.org/drawingml/2006/main"/>
           <a:p xmlns:a="http://schemas.openxmlformats.org/drawingml/2006/main">
             <a:pPr algn="r">
+              <a:buNone/>
               <a:defRPr sz="1050" b="0">
                 <a:solidFill>
                   <a:srgbClr val="6E6E73"/>
@@ -14349,6 +14762,7 @@
           <a:lstStyle xmlns:a="http://schemas.openxmlformats.org/drawingml/2006/main"/>
           <a:p xmlns:a="http://schemas.openxmlformats.org/drawingml/2006/main">
             <a:pPr algn="l">
+              <a:buNone/>
               <a:defRPr sz="1575" b="1">
                 <a:solidFill>
                   <a:srgbClr val="1D1D1F"/>
@@ -14367,7 +14781,7 @@
                 <a:ea typeface="Aptos"/>
                 <a:cs typeface="Aptos"/>
               </a:rPr>
-              <a:t>Operating point (test F1)</a:t>
+              <a:t>Exploratory test F1</a:t>
             </a:r>
           </a:p>
         </p:txBody>
@@ -14413,6 +14827,7 @@
           <a:lstStyle xmlns:a="http://schemas.openxmlformats.org/drawingml/2006/main"/>
           <a:p xmlns:a="http://schemas.openxmlformats.org/drawingml/2006/main">
             <a:pPr algn="l">
+              <a:buNone/>
               <a:defRPr sz="1125" b="0">
                 <a:solidFill>
                   <a:srgbClr val="1D1D1F"/>
@@ -14547,6 +14962,7 @@
           <a:lstStyle xmlns:a="http://schemas.openxmlformats.org/drawingml/2006/main"/>
           <a:p xmlns:a="http://schemas.openxmlformats.org/drawingml/2006/main">
             <a:pPr algn="r">
+              <a:buNone/>
               <a:defRPr sz="1050" b="0">
                 <a:solidFill>
                   <a:srgbClr val="6E6E73"/>
@@ -14611,6 +15027,7 @@
           <a:lstStyle xmlns:a="http://schemas.openxmlformats.org/drawingml/2006/main"/>
           <a:p xmlns:a="http://schemas.openxmlformats.org/drawingml/2006/main">
             <a:pPr algn="l">
+              <a:buNone/>
               <a:defRPr sz="1125" b="0">
                 <a:solidFill>
                   <a:srgbClr val="1D1D1F"/>
@@ -14745,6 +15162,7 @@
           <a:lstStyle xmlns:a="http://schemas.openxmlformats.org/drawingml/2006/main"/>
           <a:p xmlns:a="http://schemas.openxmlformats.org/drawingml/2006/main">
             <a:pPr algn="r">
+              <a:buNone/>
               <a:defRPr sz="1050" b="0">
                 <a:solidFill>
                   <a:srgbClr val="6E6E73"/>
@@ -14809,6 +15227,7 @@
           <a:lstStyle xmlns:a="http://schemas.openxmlformats.org/drawingml/2006/main"/>
           <a:p xmlns:a="http://schemas.openxmlformats.org/drawingml/2006/main">
             <a:pPr algn="l">
+              <a:buNone/>
               <a:defRPr sz="1125" b="0">
                 <a:solidFill>
                   <a:srgbClr val="1D1D1F"/>
@@ -14943,6 +15362,7 @@
           <a:lstStyle xmlns:a="http://schemas.openxmlformats.org/drawingml/2006/main"/>
           <a:p xmlns:a="http://schemas.openxmlformats.org/drawingml/2006/main">
             <a:pPr algn="r">
+              <a:buNone/>
               <a:defRPr sz="1050" b="0">
                 <a:solidFill>
                   <a:srgbClr val="6E6E73"/>
@@ -15007,6 +15427,7 @@
           <a:lstStyle xmlns:a="http://schemas.openxmlformats.org/drawingml/2006/main"/>
           <a:p xmlns:a="http://schemas.openxmlformats.org/drawingml/2006/main">
             <a:pPr algn="l">
+              <a:buNone/>
               <a:defRPr sz="1125" b="0">
                 <a:solidFill>
                   <a:srgbClr val="1D1D1F"/>
@@ -15141,6 +15562,7 @@
           <a:lstStyle xmlns:a="http://schemas.openxmlformats.org/drawingml/2006/main"/>
           <a:p xmlns:a="http://schemas.openxmlformats.org/drawingml/2006/main">
             <a:pPr algn="r">
+              <a:buNone/>
               <a:defRPr sz="1050" b="0">
                 <a:solidFill>
                   <a:srgbClr val="6E6E73"/>
@@ -15238,6 +15660,7 @@
           <a:lstStyle xmlns:a="http://schemas.openxmlformats.org/drawingml/2006/main"/>
           <a:p xmlns:a="http://schemas.openxmlformats.org/drawingml/2006/main">
             <a:pPr algn="ctr">
+              <a:buNone/>
               <a:defRPr sz="1125" b="1">
                 <a:solidFill>
                   <a:srgbClr val="0066CC"/>
@@ -15302,6 +15725,7 @@
           <a:lstStyle xmlns:a="http://schemas.openxmlformats.org/drawingml/2006/main"/>
           <a:p xmlns:a="http://schemas.openxmlformats.org/drawingml/2006/main">
             <a:pPr algn="l">
+              <a:buNone/>
               <a:defRPr sz="825" b="0">
                 <a:solidFill>
                   <a:srgbClr val="6E6E73"/>
@@ -15320,7 +15744,7 @@
                 <a:ea typeface="Aptos"/>
                 <a:cs typeface="Aptos"/>
               </a:rPr>
-              <a:t>Reported on 103 held-out test spans; thresholds selected on dev spans and reused on test.</a:t>
+              <a:t>103 test spans; dev-selected thresholds. Values are exploratory maxima across candidate signals.</a:t>
             </a:r>
           </a:p>
         </p:txBody>
@@ -15356,7 +15780,7 @@
       </p:grpSpPr>
       <p:sp>
         <p:nvSpPr>
-          <p:cNvPr id="1" name="">
+          <p:cNvPr id="36" name="">
             <a:extLst xmlns:a="http://schemas.openxmlformats.org/drawingml/2006/main">
               <a:ext uri="{FF2B5EF4-FFF2-40B4-BE49-F238E27FC236}">
                 <a16:creationId xmlns:a16="http://schemas.microsoft.com/office/drawing/2014/main" id="{20B49EE0-F1B2-40F8-8D64-C2AEF2FF89CC}"/>
@@ -15395,6 +15819,7 @@
           <a:lstStyle xmlns:a="http://schemas.openxmlformats.org/drawingml/2006/main"/>
           <a:p xmlns:a="http://schemas.openxmlformats.org/drawingml/2006/main">
             <a:pPr algn="l">
+              <a:buNone/>
               <a:defRPr sz="975" b="1">
                 <a:solidFill>
                   <a:srgbClr val="0066CC"/>
@@ -15459,6 +15884,7 @@
           <a:lstStyle xmlns:a="http://schemas.openxmlformats.org/drawingml/2006/main"/>
           <a:p xmlns:a="http://schemas.openxmlformats.org/drawingml/2006/main">
             <a:pPr algn="l">
+              <a:buNone/>
               <a:defRPr sz="2550" b="1">
                 <a:solidFill>
                   <a:srgbClr val="1D1D1F"/>
@@ -15523,6 +15949,7 @@
           <a:lstStyle xmlns:a="http://schemas.openxmlformats.org/drawingml/2006/main"/>
           <a:p xmlns:a="http://schemas.openxmlformats.org/drawingml/2006/main">
             <a:pPr algn="l">
+              <a:buNone/>
               <a:defRPr sz="1275" b="0">
                 <a:solidFill>
                   <a:srgbClr val="6E6E73"/>
@@ -15620,6 +16047,7 @@
           <a:lstStyle xmlns:a="http://schemas.openxmlformats.org/drawingml/2006/main"/>
           <a:p xmlns:a="http://schemas.openxmlformats.org/drawingml/2006/main">
             <a:pPr algn="r">
+              <a:buNone/>
               <a:defRPr sz="900" b="0">
                 <a:solidFill>
                   <a:srgbClr val="6E6E73"/>
@@ -15684,6 +16112,7 @@
           <a:lstStyle xmlns:a="http://schemas.openxmlformats.org/drawingml/2006/main"/>
           <a:p xmlns:a="http://schemas.openxmlformats.org/drawingml/2006/main">
             <a:pPr algn="l">
+              <a:buNone/>
               <a:defRPr sz="1575" b="1">
                 <a:solidFill>
                   <a:srgbClr val="0066CC"/>
@@ -15702,7 +16131,7 @@
                 <a:ea typeface="Aptos"/>
                 <a:cs typeface="Aptos"/>
               </a:rPr>
-              <a:t>Top-2 margin: best AUPRC</a:t>
+              <a:t>Top-2 margin: observed AUPRC lead</a:t>
             </a:r>
           </a:p>
         </p:txBody>
@@ -15781,6 +16210,7 @@
           <a:lstStyle xmlns:a="http://schemas.openxmlformats.org/drawingml/2006/main"/>
           <a:p xmlns:a="http://schemas.openxmlformats.org/drawingml/2006/main">
             <a:pPr algn="ctr">
+              <a:buNone/>
               <a:defRPr sz="2250" b="1">
                 <a:solidFill>
                   <a:srgbClr val="0F766E"/>
@@ -15845,6 +16275,7 @@
           <a:lstStyle xmlns:a="http://schemas.openxmlformats.org/drawingml/2006/main"/>
           <a:p xmlns:a="http://schemas.openxmlformats.org/drawingml/2006/main">
             <a:pPr algn="ctr">
+              <a:buNone/>
               <a:defRPr sz="900" b="0">
                 <a:solidFill>
                   <a:srgbClr val="6E6E73"/>
@@ -15942,6 +16373,7 @@
           <a:lstStyle xmlns:a="http://schemas.openxmlformats.org/drawingml/2006/main"/>
           <a:p xmlns:a="http://schemas.openxmlformats.org/drawingml/2006/main">
             <a:pPr algn="ctr">
+              <a:buNone/>
               <a:defRPr sz="2250" b="1">
                 <a:solidFill>
                   <a:srgbClr val="B3261E"/>
@@ -16006,6 +16438,7 @@
           <a:lstStyle xmlns:a="http://schemas.openxmlformats.org/drawingml/2006/main"/>
           <a:p xmlns:a="http://schemas.openxmlformats.org/drawingml/2006/main">
             <a:pPr algn="ctr">
+              <a:buNone/>
               <a:defRPr sz="900" b="0">
                 <a:solidFill>
                   <a:srgbClr val="6E6E73"/>
@@ -16103,6 +16536,7 @@
           <a:lstStyle xmlns:a="http://schemas.openxmlformats.org/drawingml/2006/main"/>
           <a:p xmlns:a="http://schemas.openxmlformats.org/drawingml/2006/main">
             <a:pPr algn="ctr">
+              <a:buNone/>
               <a:defRPr sz="2250" b="1">
                 <a:solidFill>
                   <a:srgbClr val="9A6700"/>
@@ -16167,6 +16601,7 @@
           <a:lstStyle xmlns:a="http://schemas.openxmlformats.org/drawingml/2006/main"/>
           <a:p xmlns:a="http://schemas.openxmlformats.org/drawingml/2006/main">
             <a:pPr algn="ctr">
+              <a:buNone/>
               <a:defRPr sz="900" b="0">
                 <a:solidFill>
                   <a:srgbClr val="6E6E73"/>
@@ -16264,6 +16699,7 @@
           <a:lstStyle xmlns:a="http://schemas.openxmlformats.org/drawingml/2006/main"/>
           <a:p xmlns:a="http://schemas.openxmlformats.org/drawingml/2006/main">
             <a:pPr algn="ctr">
+              <a:buNone/>
               <a:defRPr sz="2250" b="1">
                 <a:solidFill>
                   <a:srgbClr val="0066CC"/>
@@ -16328,6 +16764,7 @@
           <a:lstStyle xmlns:a="http://schemas.openxmlformats.org/drawingml/2006/main"/>
           <a:p xmlns:a="http://schemas.openxmlformats.org/drawingml/2006/main">
             <a:pPr algn="ctr">
+              <a:buNone/>
               <a:defRPr sz="900" b="0">
                 <a:solidFill>
                   <a:srgbClr val="6E6E73"/>
@@ -16392,6 +16829,7 @@
           <a:lstStyle xmlns:a="http://schemas.openxmlformats.org/drawingml/2006/main"/>
           <a:p xmlns:a="http://schemas.openxmlformats.org/drawingml/2006/main">
             <a:pPr algn="ctr">
+              <a:buNone/>
               <a:defRPr sz="1200" b="1">
                 <a:solidFill>
                   <a:srgbClr val="2F3A45"/>
@@ -16456,6 +16894,7 @@
           <a:lstStyle xmlns:a="http://schemas.openxmlformats.org/drawingml/2006/main"/>
           <a:p xmlns:a="http://schemas.openxmlformats.org/drawingml/2006/main">
             <a:pPr algn="l">
+              <a:buNone/>
               <a:defRPr sz="1575" b="1">
                 <a:solidFill>
                   <a:srgbClr val="9A6700"/>
@@ -16474,7 +16913,7 @@
                 <a:ea typeface="Aptos"/>
                 <a:cs typeface="Aptos"/>
               </a:rPr>
-              <a:t>Spilled mass: best energy F1</a:t>
+              <a:t>Spilled mass: observed energy-F1 lead</a:t>
             </a:r>
           </a:p>
         </p:txBody>
@@ -16553,6 +16992,7 @@
           <a:lstStyle xmlns:a="http://schemas.openxmlformats.org/drawingml/2006/main"/>
           <a:p xmlns:a="http://schemas.openxmlformats.org/drawingml/2006/main">
             <a:pPr algn="ctr">
+              <a:buNone/>
               <a:defRPr sz="2250" b="1">
                 <a:solidFill>
                   <a:srgbClr val="0F766E"/>
@@ -16617,6 +17057,7 @@
           <a:lstStyle xmlns:a="http://schemas.openxmlformats.org/drawingml/2006/main"/>
           <a:p xmlns:a="http://schemas.openxmlformats.org/drawingml/2006/main">
             <a:pPr algn="ctr">
+              <a:buNone/>
               <a:defRPr sz="900" b="0">
                 <a:solidFill>
                   <a:srgbClr val="6E6E73"/>
@@ -16714,6 +17155,7 @@
           <a:lstStyle xmlns:a="http://schemas.openxmlformats.org/drawingml/2006/main"/>
           <a:p xmlns:a="http://schemas.openxmlformats.org/drawingml/2006/main">
             <a:pPr algn="ctr">
+              <a:buNone/>
               <a:defRPr sz="2250" b="1">
                 <a:solidFill>
                   <a:srgbClr val="B3261E"/>
@@ -16778,6 +17220,7 @@
           <a:lstStyle xmlns:a="http://schemas.openxmlformats.org/drawingml/2006/main"/>
           <a:p xmlns:a="http://schemas.openxmlformats.org/drawingml/2006/main">
             <a:pPr algn="ctr">
+              <a:buNone/>
               <a:defRPr sz="900" b="0">
                 <a:solidFill>
                   <a:srgbClr val="6E6E73"/>
@@ -16875,6 +17318,7 @@
           <a:lstStyle xmlns:a="http://schemas.openxmlformats.org/drawingml/2006/main"/>
           <a:p xmlns:a="http://schemas.openxmlformats.org/drawingml/2006/main">
             <a:pPr algn="ctr">
+              <a:buNone/>
               <a:defRPr sz="2250" b="1">
                 <a:solidFill>
                   <a:srgbClr val="9A6700"/>
@@ -16939,6 +17383,7 @@
           <a:lstStyle xmlns:a="http://schemas.openxmlformats.org/drawingml/2006/main"/>
           <a:p xmlns:a="http://schemas.openxmlformats.org/drawingml/2006/main">
             <a:pPr algn="ctr">
+              <a:buNone/>
               <a:defRPr sz="900" b="0">
                 <a:solidFill>
                   <a:srgbClr val="6E6E73"/>
@@ -17036,6 +17481,7 @@
           <a:lstStyle xmlns:a="http://schemas.openxmlformats.org/drawingml/2006/main"/>
           <a:p xmlns:a="http://schemas.openxmlformats.org/drawingml/2006/main">
             <a:pPr algn="ctr">
+              <a:buNone/>
               <a:defRPr sz="2250" b="1">
                 <a:solidFill>
                   <a:srgbClr val="0066CC"/>
@@ -17100,6 +17546,7 @@
           <a:lstStyle xmlns:a="http://schemas.openxmlformats.org/drawingml/2006/main"/>
           <a:p xmlns:a="http://schemas.openxmlformats.org/drawingml/2006/main">
             <a:pPr algn="ctr">
+              <a:buNone/>
               <a:defRPr sz="900" b="0">
                 <a:solidFill>
                   <a:srgbClr val="6E6E73"/>
@@ -17164,6 +17611,7 @@
           <a:lstStyle xmlns:a="http://schemas.openxmlformats.org/drawingml/2006/main"/>
           <a:p xmlns:a="http://schemas.openxmlformats.org/drawingml/2006/main">
             <a:pPr algn="ctr">
+              <a:buNone/>
               <a:defRPr sz="1200" b="1">
                 <a:solidFill>
                   <a:srgbClr val="2F3A45"/>
@@ -17261,6 +17709,7 @@
           <a:lstStyle xmlns:a="http://schemas.openxmlformats.org/drawingml/2006/main"/>
           <a:p xmlns:a="http://schemas.openxmlformats.org/drawingml/2006/main">
             <a:pPr algn="ctr">
+              <a:buNone/>
               <a:defRPr sz="1125" b="0">
                 <a:solidFill>
                   <a:srgbClr val="2F3A45"/>
@@ -17315,7 +17764,7 @@
       </p:grpSpPr>
       <p:sp>
         <p:nvSpPr>
-          <p:cNvPr id="1" name="">
+          <p:cNvPr id="33" name="">
             <a:extLst xmlns:a="http://schemas.openxmlformats.org/drawingml/2006/main">
               <a:ext uri="{FF2B5EF4-FFF2-40B4-BE49-F238E27FC236}">
                 <a16:creationId xmlns:a16="http://schemas.microsoft.com/office/drawing/2014/main" id="{4397E5E1-F7DA-42FC-B2F6-49C6E4DA1A3C}"/>
@@ -17354,6 +17803,7 @@
           <a:lstStyle xmlns:a="http://schemas.openxmlformats.org/drawingml/2006/main"/>
           <a:p xmlns:a="http://schemas.openxmlformats.org/drawingml/2006/main">
             <a:pPr algn="l">
+              <a:buNone/>
               <a:defRPr sz="975" b="1">
                 <a:solidFill>
                   <a:srgbClr val="0066CC"/>
@@ -17418,6 +17868,7 @@
           <a:lstStyle xmlns:a="http://schemas.openxmlformats.org/drawingml/2006/main"/>
           <a:p xmlns:a="http://schemas.openxmlformats.org/drawingml/2006/main">
             <a:pPr algn="l">
+              <a:buNone/>
               <a:defRPr sz="2550" b="1">
                 <a:solidFill>
                   <a:srgbClr val="1D1D1F"/>
@@ -17482,6 +17933,7 @@
           <a:lstStyle xmlns:a="http://schemas.openxmlformats.org/drawingml/2006/main"/>
           <a:p xmlns:a="http://schemas.openxmlformats.org/drawingml/2006/main">
             <a:pPr algn="l">
+              <a:buNone/>
               <a:defRPr sz="1275" b="0">
                 <a:solidFill>
                   <a:srgbClr val="6E6E73"/>
@@ -17579,6 +18031,7 @@
           <a:lstStyle xmlns:a="http://schemas.openxmlformats.org/drawingml/2006/main"/>
           <a:p xmlns:a="http://schemas.openxmlformats.org/drawingml/2006/main">
             <a:pPr algn="r">
+              <a:buNone/>
               <a:defRPr sz="900" b="0">
                 <a:solidFill>
                   <a:srgbClr val="6E6E73"/>
@@ -17676,6 +18129,7 @@
           <a:lstStyle xmlns:a="http://schemas.openxmlformats.org/drawingml/2006/main"/>
           <a:p xmlns:a="http://schemas.openxmlformats.org/drawingml/2006/main">
             <a:pPr algn="l">
+              <a:buNone/>
               <a:defRPr sz="975" b="1">
                 <a:solidFill>
                   <a:srgbClr val="FFFFFF"/>
@@ -17740,6 +18194,7 @@
           <a:lstStyle xmlns:a="http://schemas.openxmlformats.org/drawingml/2006/main"/>
           <a:p xmlns:a="http://schemas.openxmlformats.org/drawingml/2006/main">
             <a:pPr algn="ctr">
+              <a:buNone/>
               <a:defRPr sz="975" b="1">
                 <a:solidFill>
                   <a:srgbClr val="FFFFFF"/>
@@ -17804,6 +18259,7 @@
           <a:lstStyle xmlns:a="http://schemas.openxmlformats.org/drawingml/2006/main"/>
           <a:p xmlns:a="http://schemas.openxmlformats.org/drawingml/2006/main">
             <a:pPr algn="ctr">
+              <a:buNone/>
               <a:defRPr sz="975" b="1">
                 <a:solidFill>
                   <a:srgbClr val="FFFFFF"/>
@@ -17901,6 +18357,7 @@
           <a:lstStyle xmlns:a="http://schemas.openxmlformats.org/drawingml/2006/main"/>
           <a:p xmlns:a="http://schemas.openxmlformats.org/drawingml/2006/main">
             <a:pPr algn="l">
+              <a:buNone/>
               <a:defRPr sz="1013" b="1">
                 <a:solidFill>
                   <a:srgbClr val="2F3A45"/>
@@ -17965,6 +18422,7 @@
           <a:lstStyle xmlns:a="http://schemas.openxmlformats.org/drawingml/2006/main"/>
           <a:p xmlns:a="http://schemas.openxmlformats.org/drawingml/2006/main">
             <a:pPr algn="ctr">
+              <a:buNone/>
               <a:defRPr sz="1013" b="0">
                 <a:solidFill>
                   <a:srgbClr val="2F3A45"/>
@@ -18029,6 +18487,7 @@
           <a:lstStyle xmlns:a="http://schemas.openxmlformats.org/drawingml/2006/main"/>
           <a:p xmlns:a="http://schemas.openxmlformats.org/drawingml/2006/main">
             <a:pPr algn="ctr">
+              <a:buNone/>
               <a:defRPr sz="1013" b="0">
                 <a:solidFill>
                   <a:srgbClr val="2F3A45"/>
@@ -18126,6 +18585,7 @@
           <a:lstStyle xmlns:a="http://schemas.openxmlformats.org/drawingml/2006/main"/>
           <a:p xmlns:a="http://schemas.openxmlformats.org/drawingml/2006/main">
             <a:pPr algn="l">
+              <a:buNone/>
               <a:defRPr sz="1013" b="1">
                 <a:solidFill>
                   <a:srgbClr val="2F3A45"/>
@@ -18190,6 +18650,7 @@
           <a:lstStyle xmlns:a="http://schemas.openxmlformats.org/drawingml/2006/main"/>
           <a:p xmlns:a="http://schemas.openxmlformats.org/drawingml/2006/main">
             <a:pPr algn="ctr">
+              <a:buNone/>
               <a:defRPr sz="1013" b="0">
                 <a:solidFill>
                   <a:srgbClr val="2F3A45"/>
@@ -18254,6 +18715,7 @@
           <a:lstStyle xmlns:a="http://schemas.openxmlformats.org/drawingml/2006/main"/>
           <a:p xmlns:a="http://schemas.openxmlformats.org/drawingml/2006/main">
             <a:pPr algn="ctr">
+              <a:buNone/>
               <a:defRPr sz="1013" b="0">
                 <a:solidFill>
                   <a:srgbClr val="2F3A45"/>
@@ -18351,6 +18813,7 @@
           <a:lstStyle xmlns:a="http://schemas.openxmlformats.org/drawingml/2006/main"/>
           <a:p xmlns:a="http://schemas.openxmlformats.org/drawingml/2006/main">
             <a:pPr algn="l">
+              <a:buNone/>
               <a:defRPr sz="1013" b="1">
                 <a:solidFill>
                   <a:srgbClr val="2F3A45"/>
@@ -18415,6 +18878,7 @@
           <a:lstStyle xmlns:a="http://schemas.openxmlformats.org/drawingml/2006/main"/>
           <a:p xmlns:a="http://schemas.openxmlformats.org/drawingml/2006/main">
             <a:pPr algn="ctr">
+              <a:buNone/>
               <a:defRPr sz="1013" b="0">
                 <a:solidFill>
                   <a:srgbClr val="2F3A45"/>
@@ -18479,6 +18943,7 @@
           <a:lstStyle xmlns:a="http://schemas.openxmlformats.org/drawingml/2006/main"/>
           <a:p xmlns:a="http://schemas.openxmlformats.org/drawingml/2006/main">
             <a:pPr algn="ctr">
+              <a:buNone/>
               <a:defRPr sz="1013" b="0">
                 <a:solidFill>
                   <a:srgbClr val="2F3A45"/>
@@ -18576,6 +19041,7 @@
           <a:lstStyle xmlns:a="http://schemas.openxmlformats.org/drawingml/2006/main"/>
           <a:p xmlns:a="http://schemas.openxmlformats.org/drawingml/2006/main">
             <a:pPr algn="l">
+              <a:buNone/>
               <a:defRPr sz="1013" b="1">
                 <a:solidFill>
                   <a:srgbClr val="2F3A45"/>
@@ -18640,6 +19106,7 @@
           <a:lstStyle xmlns:a="http://schemas.openxmlformats.org/drawingml/2006/main"/>
           <a:p xmlns:a="http://schemas.openxmlformats.org/drawingml/2006/main">
             <a:pPr algn="ctr">
+              <a:buNone/>
               <a:defRPr sz="1013" b="0">
                 <a:solidFill>
                   <a:srgbClr val="2F3A45"/>
@@ -18704,6 +19171,7 @@
           <a:lstStyle xmlns:a="http://schemas.openxmlformats.org/drawingml/2006/main"/>
           <a:p xmlns:a="http://schemas.openxmlformats.org/drawingml/2006/main">
             <a:pPr algn="ctr">
+              <a:buNone/>
               <a:defRPr sz="1013" b="0">
                 <a:solidFill>
                   <a:srgbClr val="2F3A45"/>
@@ -18801,6 +19269,7 @@
           <a:lstStyle xmlns:a="http://schemas.openxmlformats.org/drawingml/2006/main"/>
           <a:p xmlns:a="http://schemas.openxmlformats.org/drawingml/2006/main">
             <a:pPr algn="l">
+              <a:buNone/>
               <a:defRPr sz="1013" b="1">
                 <a:solidFill>
                   <a:srgbClr val="2F3A45"/>
@@ -18865,6 +19334,7 @@
           <a:lstStyle xmlns:a="http://schemas.openxmlformats.org/drawingml/2006/main"/>
           <a:p xmlns:a="http://schemas.openxmlformats.org/drawingml/2006/main">
             <a:pPr algn="ctr">
+              <a:buNone/>
               <a:defRPr sz="1013" b="0">
                 <a:solidFill>
                   <a:srgbClr val="2F3A45"/>
@@ -18929,6 +19399,7 @@
           <a:lstStyle xmlns:a="http://schemas.openxmlformats.org/drawingml/2006/main"/>
           <a:p xmlns:a="http://schemas.openxmlformats.org/drawingml/2006/main">
             <a:pPr algn="ctr">
+              <a:buNone/>
               <a:defRPr sz="1013" b="0">
                 <a:solidFill>
                   <a:srgbClr val="2F3A45"/>
@@ -19026,6 +19497,7 @@
           <a:lstStyle xmlns:a="http://schemas.openxmlformats.org/drawingml/2006/main"/>
           <a:p xmlns:a="http://schemas.openxmlformats.org/drawingml/2006/main">
             <a:pPr algn="l">
+              <a:buNone/>
               <a:defRPr sz="1350" b="1">
                 <a:solidFill>
                   <a:srgbClr val="B3261E"/>
@@ -19090,6 +19562,7 @@
           <a:lstStyle xmlns:a="http://schemas.openxmlformats.org/drawingml/2006/main"/>
           <a:p xmlns:a="http://schemas.openxmlformats.org/drawingml/2006/main">
             <a:pPr algn="l">
+              <a:buNone/>
               <a:defRPr sz="1125" b="0">
                 <a:solidFill>
                   <a:srgbClr val="2F3A45"/>
@@ -19108,7 +19581,7 @@
                 <a:ea typeface="Aptos"/>
                 <a:cs typeface="Aptos"/>
               </a:rPr>
-              <a:t>A detector can notice uncertain wording, but a fluent model may still make a confident rank or amount binding that is wrong relative to the evidence table.</a:t>
+              <a:t>A fluent model can bind a correct value to the wrong business fact even when its wording looks certain.</a:t>
             </a:r>
           </a:p>
         </p:txBody>
@@ -19144,7 +19617,7 @@
       </p:grpSpPr>
       <p:sp>
         <p:nvSpPr>
-          <p:cNvPr id="1" name="">
+          <p:cNvPr id="28" name="">
             <a:extLst xmlns:a="http://schemas.openxmlformats.org/drawingml/2006/main">
               <a:ext uri="{FF2B5EF4-FFF2-40B4-BE49-F238E27FC236}">
                 <a16:creationId xmlns:a16="http://schemas.microsoft.com/office/drawing/2014/main" id="{86799AAF-009F-4AF8-B67C-D0EDDC974880}"/>
@@ -19183,6 +19656,7 @@
           <a:lstStyle xmlns:a="http://schemas.openxmlformats.org/drawingml/2006/main"/>
           <a:p xmlns:a="http://schemas.openxmlformats.org/drawingml/2006/main">
             <a:pPr algn="l">
+              <a:buNone/>
               <a:defRPr sz="975" b="1">
                 <a:solidFill>
                   <a:srgbClr val="0066CC"/>
@@ -19247,6 +19721,7 @@
           <a:lstStyle xmlns:a="http://schemas.openxmlformats.org/drawingml/2006/main"/>
           <a:p xmlns:a="http://schemas.openxmlformats.org/drawingml/2006/main">
             <a:pPr algn="l">
+              <a:buNone/>
               <a:defRPr sz="2550" b="1">
                 <a:solidFill>
                   <a:srgbClr val="1D1D1F"/>
@@ -19311,6 +19786,7 @@
           <a:lstStyle xmlns:a="http://schemas.openxmlformats.org/drawingml/2006/main"/>
           <a:p xmlns:a="http://schemas.openxmlformats.org/drawingml/2006/main">
             <a:pPr algn="l">
+              <a:buNone/>
               <a:defRPr sz="1275" b="0">
                 <a:solidFill>
                   <a:srgbClr val="6E6E73"/>
@@ -19408,6 +19884,7 @@
           <a:lstStyle xmlns:a="http://schemas.openxmlformats.org/drawingml/2006/main"/>
           <a:p xmlns:a="http://schemas.openxmlformats.org/drawingml/2006/main">
             <a:pPr algn="r">
+              <a:buNone/>
               <a:defRPr sz="900" b="0">
                 <a:solidFill>
                   <a:srgbClr val="6E6E73"/>
@@ -19538,6 +20015,7 @@
           <a:lstStyle xmlns:a="http://schemas.openxmlformats.org/drawingml/2006/main"/>
           <a:p xmlns:a="http://schemas.openxmlformats.org/drawingml/2006/main">
             <a:pPr algn="l">
+              <a:buNone/>
               <a:defRPr sz="1350" b="1">
                 <a:solidFill>
                   <a:srgbClr val="0066CC"/>
@@ -19602,6 +20080,7 @@
           <a:lstStyle xmlns:a="http://schemas.openxmlformats.org/drawingml/2006/main"/>
           <a:p xmlns:a="http://schemas.openxmlformats.org/drawingml/2006/main">
             <a:pPr algn="l">
+              <a:buNone/>
               <a:defRPr sz="1013" b="0">
                 <a:solidFill>
                   <a:srgbClr val="2F3A45"/>
@@ -19699,6 +20178,7 @@
           <a:lstStyle xmlns:a="http://schemas.openxmlformats.org/drawingml/2006/main"/>
           <a:p xmlns:a="http://schemas.openxmlformats.org/drawingml/2006/main">
             <a:pPr algn="l">
+              <a:buNone/>
               <a:defRPr sz="900" b="1">
                 <a:solidFill>
                   <a:srgbClr val="0F766E"/>
@@ -19763,6 +20243,7 @@
           <a:lstStyle xmlns:a="http://schemas.openxmlformats.org/drawingml/2006/main"/>
           <a:p xmlns:a="http://schemas.openxmlformats.org/drawingml/2006/main">
             <a:pPr algn="l">
+              <a:buNone/>
               <a:defRPr sz="900" b="0">
                 <a:solidFill>
                   <a:srgbClr val="2F3A45"/>
@@ -19860,6 +20341,7 @@
           <a:lstStyle xmlns:a="http://schemas.openxmlformats.org/drawingml/2006/main"/>
           <a:p xmlns:a="http://schemas.openxmlformats.org/drawingml/2006/main">
             <a:pPr algn="l">
+              <a:buNone/>
               <a:defRPr sz="900" b="1">
                 <a:solidFill>
                   <a:srgbClr val="B3261E"/>
@@ -19924,6 +20406,7 @@
           <a:lstStyle xmlns:a="http://schemas.openxmlformats.org/drawingml/2006/main"/>
           <a:p xmlns:a="http://schemas.openxmlformats.org/drawingml/2006/main">
             <a:pPr algn="l">
+              <a:buNone/>
               <a:defRPr sz="900" b="0">
                 <a:solidFill>
                   <a:srgbClr val="2F3A45"/>
@@ -19988,6 +20471,7 @@
           <a:lstStyle xmlns:a="http://schemas.openxmlformats.org/drawingml/2006/main"/>
           <a:p xmlns:a="http://schemas.openxmlformats.org/drawingml/2006/main">
             <a:pPr algn="l">
+              <a:buNone/>
               <a:defRPr sz="1088" b="1">
                 <a:solidFill>
                   <a:srgbClr val="2F3A45"/>
@@ -20118,6 +20602,7 @@
           <a:lstStyle xmlns:a="http://schemas.openxmlformats.org/drawingml/2006/main"/>
           <a:p xmlns:a="http://schemas.openxmlformats.org/drawingml/2006/main">
             <a:pPr algn="l">
+              <a:buNone/>
               <a:defRPr sz="1350" b="1">
                 <a:solidFill>
                   <a:srgbClr val="B3261E"/>
@@ -20182,6 +20667,7 @@
           <a:lstStyle xmlns:a="http://schemas.openxmlformats.org/drawingml/2006/main"/>
           <a:p xmlns:a="http://schemas.openxmlformats.org/drawingml/2006/main">
             <a:pPr algn="l">
+              <a:buNone/>
               <a:defRPr sz="1013" b="0">
                 <a:solidFill>
                   <a:srgbClr val="2F3A45"/>
@@ -20279,6 +20765,7 @@
           <a:lstStyle xmlns:a="http://schemas.openxmlformats.org/drawingml/2006/main"/>
           <a:p xmlns:a="http://schemas.openxmlformats.org/drawingml/2006/main">
             <a:pPr algn="l">
+              <a:buNone/>
               <a:defRPr sz="900" b="1">
                 <a:solidFill>
                   <a:srgbClr val="0F766E"/>
@@ -20343,6 +20830,7 @@
           <a:lstStyle xmlns:a="http://schemas.openxmlformats.org/drawingml/2006/main"/>
           <a:p xmlns:a="http://schemas.openxmlformats.org/drawingml/2006/main">
             <a:pPr algn="l">
+              <a:buNone/>
               <a:defRPr sz="900" b="0">
                 <a:solidFill>
                   <a:srgbClr val="2F3A45"/>
@@ -20440,6 +20928,7 @@
           <a:lstStyle xmlns:a="http://schemas.openxmlformats.org/drawingml/2006/main"/>
           <a:p xmlns:a="http://schemas.openxmlformats.org/drawingml/2006/main">
             <a:pPr algn="l">
+              <a:buNone/>
               <a:defRPr sz="900" b="1">
                 <a:solidFill>
                   <a:srgbClr val="B3261E"/>
@@ -20504,6 +20993,7 @@
           <a:lstStyle xmlns:a="http://schemas.openxmlformats.org/drawingml/2006/main"/>
           <a:p xmlns:a="http://schemas.openxmlformats.org/drawingml/2006/main">
             <a:pPr algn="l">
+              <a:buNone/>
               <a:defRPr sz="900" b="0">
                 <a:solidFill>
                   <a:srgbClr val="2F3A45"/>
@@ -20568,6 +21058,7 @@
           <a:lstStyle xmlns:a="http://schemas.openxmlformats.org/drawingml/2006/main"/>
           <a:p xmlns:a="http://schemas.openxmlformats.org/drawingml/2006/main">
             <a:pPr algn="l">
+              <a:buNone/>
               <a:defRPr sz="1088" b="1">
                 <a:solidFill>
                   <a:srgbClr val="2F3A45"/>

</xml_diff>